<commit_message>
Add escalation/handover and refund policy slides to operations deck
Co-Authored-By: Claude Opus 5.5 <noreply@anthropic.com>
Claude-Session: https://claude.ai/code/session_01QCcem4ARLw1FnHwcvX9EVJ
</commit_message>
<xml_diff>
--- a/Medcity_Operations_Workflow.pptx
+++ b/Medcity_Operations_Workflow.pptx
@@ -17,9 +17,13 @@
     <p:sldId id="265" r:id="rId11"/>
     <p:sldId id="266" r:id="rId12"/>
     <p:sldId id="267" r:id="rId13"/>
+    <p:sldId id="268" r:id="rId14"/>
+    <p:sldId id="269" r:id="rId15"/>
+    <p:sldId id="270" r:id="rId16"/>
+    <p:sldId id="271" r:id="rId17"/>
   </p:sldIdLst>
   <p:notesMasterIdLst>
-    <p:notesMasterId r:id="rId14"/>
+    <p:notesMasterId r:id="rId18"/>
   </p:notesMasterIdLst>
   <p:sldSz cx="9144000" cy="5143500"/>
   <p:notesSz cx="5143500" cy="9144000"/>
@@ -601,7 +605,7 @@
           <a:p>
             <a:r>
               <a:rPr lang="en-US" dirty="0"/>
-              <a:t>This summarises ownership. When a file is stuck, check this table to see who holds it and who they hand over to.</a:t>
+              <a:t>Every escalation must copy the Operations Manager and the concerned department, with no delay. Before anyone goes on leave, they must hand over every document detail and file status to their cover. Leave is not possible until the handover is complete.</a:t>
             </a:r>
             <a:endParaRPr lang="en-US" dirty="0"/>
           </a:p>
@@ -689,7 +693,7 @@
           <a:p>
             <a:r>
               <a:rPr lang="en-US" dirty="0"/>
-              <a:t>These six rules sum up the session. If everyone follows them, no file gets lost and no family is left without information.</a:t>
+              <a:t>This summarises ownership. When a file is stuck, check this table to see who holds it and who they hand over to.</a:t>
             </a:r>
             <a:endParaRPr lang="en-US" dirty="0"/>
           </a:p>
@@ -777,7 +781,7 @@
           <a:p>
             <a:r>
               <a:rPr lang="en-US" dirty="0"/>
-              <a:t>Open the floor for questions. Remind the team that the process only works if every step is updated on time.</a:t>
+              <a:t>These six rules sum up the session. If everyone follows them, no file gets lost and no family is left without information.</a:t>
             </a:r>
             <a:endParaRPr lang="en-US" dirty="0"/>
           </a:p>
@@ -801,6 +805,358 @@
             <a:fld id="{F7021451-1387-4CA6-816F-3879F97B5CBC}" type="slidenum">
               <a:rPr lang="en-US"/>
               <a:t>12</a:t>
+            </a:fld>
+            <a:endParaRPr lang="en-US"/>
+          </a:p>
+        </p:txBody>
+      </p:sp>
+    </p:spTree>
+    <p:extLst>
+      <p:ext uri="{BB962C8B-B14F-4D97-AF65-F5344CB8AC3E}">
+        <p14:creationId xmlns:p14="http://schemas.microsoft.com/office/powerpoint/2010/main" val="1024086991"/>
+      </p:ext>
+    </p:extLst>
+  </p:cSld>
+  <p:clrMapOvr>
+    <a:masterClrMapping/>
+  </p:clrMapOvr>
+</p:notes>
+</file>
+
+<file path=ppt/notesSlides/notesSlide13.xml><?xml version="1.0" encoding="utf-8"?>
+<p:notes xmlns:a="http://schemas.openxmlformats.org/drawingml/2006/main" xmlns:r="http://schemas.openxmlformats.org/officeDocument/2006/relationships" xmlns:p="http://schemas.openxmlformats.org/presentationml/2006/main">
+  <p:cSld>
+    <p:spTree>
+      <p:nvGrpSpPr>
+        <p:cNvPr id="1" name=""/>
+        <p:cNvGrpSpPr/>
+        <p:nvPr/>
+      </p:nvGrpSpPr>
+      <p:grpSpPr>
+        <a:xfrm>
+          <a:off x="0" y="0"/>
+          <a:ext cx="0" cy="0"/>
+          <a:chOff x="0" y="0"/>
+          <a:chExt cx="0" cy="0"/>
+        </a:xfrm>
+      </p:grpSpPr>
+      <p:sp>
+        <p:nvSpPr>
+          <p:cNvPr id="2" name="Slide Image Placeholder 1"/>
+          <p:cNvSpPr>
+            <a:spLocks noGrp="1" noRot="1" noChangeAspect="1"/>
+          </p:cNvSpPr>
+          <p:nvPr>
+            <p:ph type="sldImg"/>
+          </p:nvPr>
+        </p:nvSpPr>
+        <p:spPr/>
+      </p:sp>
+      <p:sp>
+        <p:nvSpPr>
+          <p:cNvPr id="3" name="Notes Placeholder 2"/>
+          <p:cNvSpPr>
+            <a:spLocks noGrp="1"/>
+          </p:cNvSpPr>
+          <p:nvPr>
+            <p:ph type="body" idx="1"/>
+          </p:nvPr>
+        </p:nvSpPr>
+        <p:spPr/>
+        <p:txBody>
+          <a:bodyPr/>
+          <a:lstStyle/>
+          <a:p>
+            <a:r>
+              <a:rPr lang="en-US" dirty="0"/>
+              <a:t>We are refining and standardising the Study Abroad Refund Policy. From now on, all refund requests follow the process in the next two slides.</a:t>
+            </a:r>
+            <a:endParaRPr lang="en-US" dirty="0"/>
+          </a:p>
+        </p:txBody>
+      </p:sp>
+      <p:sp>
+        <p:nvSpPr>
+          <p:cNvPr id="4" name="Slide Number Placeholder 3"/>
+          <p:cNvSpPr>
+            <a:spLocks noGrp="1"/>
+          </p:cNvSpPr>
+          <p:nvPr>
+            <p:ph type="sldNum" sz="quarter" idx="10"/>
+          </p:nvPr>
+        </p:nvSpPr>
+        <p:spPr/>
+        <p:txBody>
+          <a:bodyPr/>
+          <a:lstStyle/>
+          <a:p>
+            <a:fld id="{F7021451-1387-4CA6-816F-3879F97B5CBC}" type="slidenum">
+              <a:rPr lang="en-US"/>
+              <a:t>13</a:t>
+            </a:fld>
+            <a:endParaRPr lang="en-US"/>
+          </a:p>
+        </p:txBody>
+      </p:sp>
+    </p:spTree>
+    <p:extLst>
+      <p:ext uri="{BB962C8B-B14F-4D97-AF65-F5344CB8AC3E}">
+        <p14:creationId xmlns:p14="http://schemas.microsoft.com/office/powerpoint/2010/main" val="1024086991"/>
+      </p:ext>
+    </p:extLst>
+  </p:cSld>
+  <p:clrMapOvr>
+    <a:masterClrMapping/>
+  </p:clrMapOvr>
+</p:notes>
+</file>
+
+<file path=ppt/notesSlides/notesSlide14.xml><?xml version="1.0" encoding="utf-8"?>
+<p:notes xmlns:a="http://schemas.openxmlformats.org/drawingml/2006/main" xmlns:r="http://schemas.openxmlformats.org/officeDocument/2006/relationships" xmlns:p="http://schemas.openxmlformats.org/presentationml/2006/main">
+  <p:cSld>
+    <p:spTree>
+      <p:nvGrpSpPr>
+        <p:cNvPr id="1" name=""/>
+        <p:cNvGrpSpPr/>
+        <p:nvPr/>
+      </p:nvGrpSpPr>
+      <p:grpSpPr>
+        <a:xfrm>
+          <a:off x="0" y="0"/>
+          <a:ext cx="0" cy="0"/>
+          <a:chOff x="0" y="0"/>
+          <a:chExt cx="0" cy="0"/>
+        </a:xfrm>
+      </p:grpSpPr>
+      <p:sp>
+        <p:nvSpPr>
+          <p:cNvPr id="2" name="Slide Image Placeholder 1"/>
+          <p:cNvSpPr>
+            <a:spLocks noGrp="1" noRot="1" noChangeAspect="1"/>
+          </p:cNvSpPr>
+          <p:nvPr>
+            <p:ph type="sldImg"/>
+          </p:nvPr>
+        </p:nvSpPr>
+        <p:spPr/>
+      </p:sp>
+      <p:sp>
+        <p:nvSpPr>
+          <p:cNvPr id="3" name="Notes Placeholder 2"/>
+          <p:cNvSpPr>
+            <a:spLocks noGrp="1"/>
+          </p:cNvSpPr>
+          <p:nvPr>
+            <p:ph type="body" idx="1"/>
+          </p:nvPr>
+        </p:nvSpPr>
+        <p:spPr/>
+        <p:txBody>
+          <a:bodyPr/>
+          <a:lstStyle/>
+          <a:p>
+            <a:r>
+              <a:rPr lang="en-US" dirty="0"/>
+              <a:t>The refund workflow: the counsellor completes the Refund Request Form, emails it to the Branch Head or Regional Manager, who verifies and forwards it to the International Relations Manager with the ATL in CC. The IRM then verifies everything. Nothing proceeds while there is a discrepancy.</a:t>
+            </a:r>
+            <a:endParaRPr lang="en-US" dirty="0"/>
+          </a:p>
+        </p:txBody>
+      </p:sp>
+      <p:sp>
+        <p:nvSpPr>
+          <p:cNvPr id="4" name="Slide Number Placeholder 3"/>
+          <p:cNvSpPr>
+            <a:spLocks noGrp="1"/>
+          </p:cNvSpPr>
+          <p:nvPr>
+            <p:ph type="sldNum" sz="quarter" idx="10"/>
+          </p:nvPr>
+        </p:nvSpPr>
+        <p:spPr/>
+        <p:txBody>
+          <a:bodyPr/>
+          <a:lstStyle/>
+          <a:p>
+            <a:fld id="{F7021451-1387-4CA6-816F-3879F97B5CBC}" type="slidenum">
+              <a:rPr lang="en-US"/>
+              <a:t>14</a:t>
+            </a:fld>
+            <a:endParaRPr lang="en-US"/>
+          </a:p>
+        </p:txBody>
+      </p:sp>
+    </p:spTree>
+    <p:extLst>
+      <p:ext uri="{BB962C8B-B14F-4D97-AF65-F5344CB8AC3E}">
+        <p14:creationId xmlns:p14="http://schemas.microsoft.com/office/powerpoint/2010/main" val="1024086991"/>
+      </p:ext>
+    </p:extLst>
+  </p:cSld>
+  <p:clrMapOvr>
+    <a:masterClrMapping/>
+  </p:clrMapOvr>
+</p:notes>
+</file>
+
+<file path=ppt/notesSlides/notesSlide15.xml><?xml version="1.0" encoding="utf-8"?>
+<p:notes xmlns:a="http://schemas.openxmlformats.org/drawingml/2006/main" xmlns:r="http://schemas.openxmlformats.org/officeDocument/2006/relationships" xmlns:p="http://schemas.openxmlformats.org/presentationml/2006/main">
+  <p:cSld>
+    <p:spTree>
+      <p:nvGrpSpPr>
+        <p:cNvPr id="1" name=""/>
+        <p:cNvGrpSpPr/>
+        <p:nvPr/>
+      </p:nvGrpSpPr>
+      <p:grpSpPr>
+        <a:xfrm>
+          <a:off x="0" y="0"/>
+          <a:ext cx="0" cy="0"/>
+          <a:chOff x="0" y="0"/>
+          <a:chExt cx="0" cy="0"/>
+        </a:xfrm>
+      </p:grpSpPr>
+      <p:sp>
+        <p:nvSpPr>
+          <p:cNvPr id="2" name="Slide Image Placeholder 1"/>
+          <p:cNvSpPr>
+            <a:spLocks noGrp="1" noRot="1" noChangeAspect="1"/>
+          </p:cNvSpPr>
+          <p:nvPr>
+            <p:ph type="sldImg"/>
+          </p:nvPr>
+        </p:nvSpPr>
+        <p:spPr/>
+      </p:sp>
+      <p:sp>
+        <p:nvSpPr>
+          <p:cNvPr id="3" name="Notes Placeholder 2"/>
+          <p:cNvSpPr>
+            <a:spLocks noGrp="1"/>
+          </p:cNvSpPr>
+          <p:nvPr>
+            <p:ph type="body" idx="1"/>
+          </p:nvPr>
+        </p:nvSpPr>
+        <p:spPr/>
+        <p:txBody>
+          <a:bodyPr/>
+          <a:lstStyle/>
+          <a:p>
+            <a:r>
+              <a:rPr lang="en-US" dirty="0"/>
+              <a:t>Incentives already received or claimed must be declared by the counsellor because they are considered during refund verification and settlement. The IRM checks application status, payments, services provided, commitments and documentation before the request can proceed.</a:t>
+            </a:r>
+            <a:endParaRPr lang="en-US" dirty="0"/>
+          </a:p>
+        </p:txBody>
+      </p:sp>
+      <p:sp>
+        <p:nvSpPr>
+          <p:cNvPr id="4" name="Slide Number Placeholder 3"/>
+          <p:cNvSpPr>
+            <a:spLocks noGrp="1"/>
+          </p:cNvSpPr>
+          <p:nvPr>
+            <p:ph type="sldNum" sz="quarter" idx="10"/>
+          </p:nvPr>
+        </p:nvSpPr>
+        <p:spPr/>
+        <p:txBody>
+          <a:bodyPr/>
+          <a:lstStyle/>
+          <a:p>
+            <a:fld id="{F7021451-1387-4CA6-816F-3879F97B5CBC}" type="slidenum">
+              <a:rPr lang="en-US"/>
+              <a:t>15</a:t>
+            </a:fld>
+            <a:endParaRPr lang="en-US"/>
+          </a:p>
+        </p:txBody>
+      </p:sp>
+    </p:spTree>
+    <p:extLst>
+      <p:ext uri="{BB962C8B-B14F-4D97-AF65-F5344CB8AC3E}">
+        <p14:creationId xmlns:p14="http://schemas.microsoft.com/office/powerpoint/2010/main" val="1024086991"/>
+      </p:ext>
+    </p:extLst>
+  </p:cSld>
+  <p:clrMapOvr>
+    <a:masterClrMapping/>
+  </p:clrMapOvr>
+</p:notes>
+</file>
+
+<file path=ppt/notesSlides/notesSlide16.xml><?xml version="1.0" encoding="utf-8"?>
+<p:notes xmlns:a="http://schemas.openxmlformats.org/drawingml/2006/main" xmlns:r="http://schemas.openxmlformats.org/officeDocument/2006/relationships" xmlns:p="http://schemas.openxmlformats.org/presentationml/2006/main">
+  <p:cSld>
+    <p:spTree>
+      <p:nvGrpSpPr>
+        <p:cNvPr id="1" name=""/>
+        <p:cNvGrpSpPr/>
+        <p:nvPr/>
+      </p:nvGrpSpPr>
+      <p:grpSpPr>
+        <a:xfrm>
+          <a:off x="0" y="0"/>
+          <a:ext cx="0" cy="0"/>
+          <a:chOff x="0" y="0"/>
+          <a:chExt cx="0" cy="0"/>
+        </a:xfrm>
+      </p:grpSpPr>
+      <p:sp>
+        <p:nvSpPr>
+          <p:cNvPr id="2" name="Slide Image Placeholder 1"/>
+          <p:cNvSpPr>
+            <a:spLocks noGrp="1" noRot="1" noChangeAspect="1"/>
+          </p:cNvSpPr>
+          <p:nvPr>
+            <p:ph type="sldImg"/>
+          </p:nvPr>
+        </p:nvSpPr>
+        <p:spPr/>
+      </p:sp>
+      <p:sp>
+        <p:nvSpPr>
+          <p:cNvPr id="3" name="Notes Placeholder 2"/>
+          <p:cNvSpPr>
+            <a:spLocks noGrp="1"/>
+          </p:cNvSpPr>
+          <p:nvPr>
+            <p:ph type="body" idx="1"/>
+          </p:nvPr>
+        </p:nvSpPr>
+        <p:spPr/>
+        <p:txBody>
+          <a:bodyPr/>
+          <a:lstStyle/>
+          <a:p>
+            <a:r>
+              <a:rPr lang="en-US" dirty="0"/>
+              <a:t>Open the floor for questions. Remind the team that the process only works if every step is updated on time.</a:t>
+            </a:r>
+            <a:endParaRPr lang="en-US" dirty="0"/>
+          </a:p>
+        </p:txBody>
+      </p:sp>
+      <p:sp>
+        <p:nvSpPr>
+          <p:cNvPr id="4" name="Slide Number Placeholder 3"/>
+          <p:cNvSpPr>
+            <a:spLocks noGrp="1"/>
+          </p:cNvSpPr>
+          <p:nvPr>
+            <p:ph type="sldNum" sz="quarter" idx="10"/>
+          </p:nvPr>
+        </p:nvSpPr>
+        <p:spPr/>
+        <p:txBody>
+          <a:bodyPr/>
+          <a:lstStyle/>
+          <a:p>
+            <a:fld id="{F7021451-1387-4CA6-816F-3879F97B5CBC}" type="slidenum">
+              <a:rPr lang="en-US"/>
+              <a:t>16</a:t>
             </a:fld>
             <a:endParaRPr lang="en-US"/>
           </a:p>
@@ -2099,7 +2455,7 @@
                 <a:ea typeface="Arial" pitchFamily="34" charset="-122"/>
                 <a:cs typeface="Arial" pitchFamily="34" charset="-120"/>
               </a:rPr>
-              <a:t>Who Owns What</a:t>
+              <a:t>Escalations &amp; Handover</a:t>
             </a:r>
             <a:endParaRPr lang="en-US" sz="2600" dirty="0"/>
           </a:p>
@@ -2138,7 +2494,7 @@
                 <a:ea typeface="Calibri" pitchFamily="34" charset="-122"/>
                 <a:cs typeface="Calibri" pitchFamily="34" charset="-120"/>
               </a:rPr>
-              <a:t>Clear ownership keeps every file moving</a:t>
+              <a:t>No lag, no gaps — ever</a:t>
             </a:r>
             <a:endParaRPr lang="en-US" sz="1300" dirty="0"/>
           </a:p>
@@ -2168,9 +2524,1097 @@
           </a:prstGeom>
         </p:spPr>
       </p:pic>
+      <p:sp>
+        <p:nvSpPr>
+          <p:cNvPr id="5" name="Shape 2"/>
+          <p:cNvSpPr/>
+          <p:nvPr/>
+        </p:nvSpPr>
+        <p:spPr>
+          <a:xfrm>
+            <a:off x="457200" y="1234440"/>
+            <a:ext cx="3977640" cy="3429000"/>
+          </a:xfrm>
+          <a:prstGeom prst="roundRect">
+            <a:avLst>
+              <a:gd name="adj" fmla="val 4000"/>
+            </a:avLst>
+          </a:prstGeom>
+          <a:solidFill>
+            <a:srgbClr val="C01F53"/>
+          </a:solidFill>
+          <a:ln w="12700">
+            <a:solidFill>
+              <a:srgbClr val="C01F53"/>
+            </a:solidFill>
+            <a:prstDash val="solid"/>
+          </a:ln>
+        </p:spPr>
+      </p:sp>
+      <p:sp>
+        <p:nvSpPr>
+          <p:cNvPr id="6" name="Shape 3"/>
+          <p:cNvSpPr/>
+          <p:nvPr/>
+        </p:nvSpPr>
+        <p:spPr>
+          <a:xfrm>
+            <a:off x="731520" y="1463040"/>
+            <a:ext cx="594360" cy="594360"/>
+          </a:xfrm>
+          <a:prstGeom prst="ellipse">
+            <a:avLst/>
+          </a:prstGeom>
+          <a:solidFill>
+            <a:srgbClr val="EDE72D"/>
+          </a:solidFill>
+          <a:ln w="12700">
+            <a:solidFill>
+              <a:srgbClr val="EDE72D"/>
+            </a:solidFill>
+            <a:prstDash val="solid"/>
+          </a:ln>
+        </p:spPr>
+      </p:sp>
+      <p:pic>
+        <p:nvPicPr>
+          <p:cNvPr id="7" name="Image 1" descr="preencoded.png">    </p:cNvPr>
+          <p:cNvPicPr>
+            <a:picLocks noChangeAspect="1"/>
+          </p:cNvPicPr>
+          <p:nvPr/>
+        </p:nvPicPr>
+        <p:blipFill>
+          <a:blip r:embed="rId2"/>
+          <a:stretch>
+            <a:fillRect/>
+          </a:stretch>
+        </p:blipFill>
+        <p:spPr>
+          <a:xfrm>
+            <a:off x="880110" y="1611630"/>
+            <a:ext cx="297180" cy="297180"/>
+          </a:xfrm>
+          <a:prstGeom prst="rect">
+            <a:avLst/>
+          </a:prstGeom>
+        </p:spPr>
+      </p:pic>
+      <p:sp>
+        <p:nvSpPr>
+          <p:cNvPr id="8" name="Text 4"/>
+          <p:cNvSpPr txBox="1"/>
+          <p:nvPr/>
+        </p:nvSpPr>
+        <p:spPr>
+          <a:xfrm>
+            <a:off x="1463040" y="1463040"/>
+            <a:ext cx="2834640" cy="594360"/>
+          </a:xfrm>
+          <a:prstGeom prst="rect">
+            <a:avLst/>
+          </a:prstGeom>
+          <a:noFill/>
+          <a:ln/>
+        </p:spPr>
+        <p:txBody>
+          <a:bodyPr wrap="square" lIns="0" tIns="0" rIns="0" bIns="0" rtlCol="0" anchor="ctr"/>
+          <a:lstStyle/>
+          <a:p>
+            <a:pPr indent="0" marL="0">
+              <a:buNone/>
+            </a:pPr>
+            <a:r>
+              <a:rPr lang="en-US" sz="1800" b="1" dirty="0">
+                <a:solidFill>
+                  <a:srgbClr val="FFFFFF"/>
+                </a:solidFill>
+                <a:latin typeface="Arial" pitchFamily="34" charset="0"/>
+                <a:ea typeface="Arial" pitchFamily="34" charset="-122"/>
+                <a:cs typeface="Arial" pitchFamily="34" charset="-120"/>
+              </a:rPr>
+              <a:t>Any escalation</a:t>
+            </a:r>
+            <a:endParaRPr lang="en-US" sz="1800" dirty="0"/>
+          </a:p>
+        </p:txBody>
+      </p:sp>
+      <p:sp>
+        <p:nvSpPr>
+          <p:cNvPr id="9" name="Text 5"/>
+          <p:cNvSpPr txBox="1"/>
+          <p:nvPr/>
+        </p:nvSpPr>
+        <p:spPr>
+          <a:xfrm>
+            <a:off x="731520" y="2240280"/>
+            <a:ext cx="3474720" cy="274320"/>
+          </a:xfrm>
+          <a:prstGeom prst="rect">
+            <a:avLst/>
+          </a:prstGeom>
+          <a:noFill/>
+          <a:ln/>
+        </p:spPr>
+        <p:txBody>
+          <a:bodyPr wrap="square" lIns="0" tIns="0" rIns="0" bIns="0" rtlCol="0" anchor="ctr"/>
+          <a:lstStyle/>
+          <a:p>
+            <a:pPr indent="0" marL="0">
+              <a:buNone/>
+            </a:pPr>
+            <a:r>
+              <a:rPr lang="en-US" sz="1300" dirty="0">
+                <a:solidFill>
+                  <a:srgbClr val="F6C9D7"/>
+                </a:solidFill>
+                <a:latin typeface="Calibri" pitchFamily="34" charset="0"/>
+                <a:ea typeface="Calibri" pitchFamily="34" charset="-122"/>
+                <a:cs typeface="Calibri" pitchFamily="34" charset="-120"/>
+              </a:rPr>
+              <a:t>Always keep in CC:</a:t>
+            </a:r>
+            <a:endParaRPr lang="en-US" sz="1300" dirty="0"/>
+          </a:p>
+        </p:txBody>
+      </p:sp>
+      <p:sp>
+        <p:nvSpPr>
+          <p:cNvPr id="10" name="Shape 6"/>
+          <p:cNvSpPr/>
+          <p:nvPr/>
+        </p:nvSpPr>
+        <p:spPr>
+          <a:xfrm>
+            <a:off x="731520" y="2606040"/>
+            <a:ext cx="3429000" cy="438912"/>
+          </a:xfrm>
+          <a:prstGeom prst="roundRect">
+            <a:avLst>
+              <a:gd name="adj" fmla="val 16667"/>
+            </a:avLst>
+          </a:prstGeom>
+          <a:solidFill>
+            <a:srgbClr val="FFFFFF"/>
+          </a:solidFill>
+          <a:ln w="12700">
+            <a:solidFill>
+              <a:srgbClr val="FFFFFF"/>
+            </a:solidFill>
+            <a:prstDash val="solid"/>
+          </a:ln>
+        </p:spPr>
+      </p:sp>
+      <p:sp>
+        <p:nvSpPr>
+          <p:cNvPr id="11" name="Text 7"/>
+          <p:cNvSpPr txBox="1"/>
+          <p:nvPr/>
+        </p:nvSpPr>
+        <p:spPr>
+          <a:xfrm>
+            <a:off x="868680" y="2606040"/>
+            <a:ext cx="3200400" cy="438912"/>
+          </a:xfrm>
+          <a:prstGeom prst="rect">
+            <a:avLst/>
+          </a:prstGeom>
+          <a:noFill/>
+          <a:ln/>
+        </p:spPr>
+        <p:txBody>
+          <a:bodyPr wrap="square" lIns="0" tIns="0" rIns="0" bIns="0" rtlCol="0" anchor="ctr"/>
+          <a:lstStyle/>
+          <a:p>
+            <a:pPr indent="0" marL="0">
+              <a:buNone/>
+            </a:pPr>
+            <a:r>
+              <a:rPr lang="en-US" sz="1400" b="1" dirty="0">
+                <a:solidFill>
+                  <a:srgbClr val="C01F53"/>
+                </a:solidFill>
+                <a:latin typeface="Calibri" pitchFamily="34" charset="0"/>
+                <a:ea typeface="Calibri" pitchFamily="34" charset="-122"/>
+                <a:cs typeface="Calibri" pitchFamily="34" charset="-120"/>
+              </a:rPr>
+              <a:t>CC  </a:t>
+            </a:r>
+            <a:pPr indent="0" marL="0">
+              <a:buNone/>
+            </a:pPr>
+            <a:r>
+              <a:rPr lang="en-US" sz="1400" b="1" dirty="0">
+                <a:solidFill>
+                  <a:srgbClr val="2B1A22"/>
+                </a:solidFill>
+                <a:latin typeface="Calibri" pitchFamily="34" charset="0"/>
+                <a:ea typeface="Calibri" pitchFamily="34" charset="-122"/>
+                <a:cs typeface="Calibri" pitchFamily="34" charset="-120"/>
+              </a:rPr>
+              <a:t>Operations Manager</a:t>
+            </a:r>
+            <a:endParaRPr lang="en-US" sz="1400" dirty="0"/>
+          </a:p>
+        </p:txBody>
+      </p:sp>
+      <p:sp>
+        <p:nvSpPr>
+          <p:cNvPr id="12" name="Shape 8"/>
+          <p:cNvSpPr/>
+          <p:nvPr/>
+        </p:nvSpPr>
+        <p:spPr>
+          <a:xfrm>
+            <a:off x="731520" y="3154680"/>
+            <a:ext cx="3429000" cy="438912"/>
+          </a:xfrm>
+          <a:prstGeom prst="roundRect">
+            <a:avLst>
+              <a:gd name="adj" fmla="val 16667"/>
+            </a:avLst>
+          </a:prstGeom>
+          <a:solidFill>
+            <a:srgbClr val="FFFFFF"/>
+          </a:solidFill>
+          <a:ln w="12700">
+            <a:solidFill>
+              <a:srgbClr val="FFFFFF"/>
+            </a:solidFill>
+            <a:prstDash val="solid"/>
+          </a:ln>
+        </p:spPr>
+      </p:sp>
+      <p:sp>
+        <p:nvSpPr>
+          <p:cNvPr id="13" name="Text 9"/>
+          <p:cNvSpPr txBox="1"/>
+          <p:nvPr/>
+        </p:nvSpPr>
+        <p:spPr>
+          <a:xfrm>
+            <a:off x="868680" y="3154680"/>
+            <a:ext cx="3200400" cy="438912"/>
+          </a:xfrm>
+          <a:prstGeom prst="rect">
+            <a:avLst/>
+          </a:prstGeom>
+          <a:noFill/>
+          <a:ln/>
+        </p:spPr>
+        <p:txBody>
+          <a:bodyPr wrap="square" lIns="0" tIns="0" rIns="0" bIns="0" rtlCol="0" anchor="ctr"/>
+          <a:lstStyle/>
+          <a:p>
+            <a:pPr indent="0" marL="0">
+              <a:buNone/>
+            </a:pPr>
+            <a:r>
+              <a:rPr lang="en-US" sz="1400" b="1" dirty="0">
+                <a:solidFill>
+                  <a:srgbClr val="C01F53"/>
+                </a:solidFill>
+                <a:latin typeface="Calibri" pitchFamily="34" charset="0"/>
+                <a:ea typeface="Calibri" pitchFamily="34" charset="-122"/>
+                <a:cs typeface="Calibri" pitchFamily="34" charset="-120"/>
+              </a:rPr>
+              <a:t>CC  </a:t>
+            </a:r>
+            <a:pPr indent="0" marL="0">
+              <a:buNone/>
+            </a:pPr>
+            <a:r>
+              <a:rPr lang="en-US" sz="1400" b="1" dirty="0">
+                <a:solidFill>
+                  <a:srgbClr val="2B1A22"/>
+                </a:solidFill>
+                <a:latin typeface="Calibri" pitchFamily="34" charset="0"/>
+                <a:ea typeface="Calibri" pitchFamily="34" charset="-122"/>
+                <a:cs typeface="Calibri" pitchFamily="34" charset="-120"/>
+              </a:rPr>
+              <a:t>Concerned department</a:t>
+            </a:r>
+            <a:endParaRPr lang="en-US" sz="1400" dirty="0"/>
+          </a:p>
+        </p:txBody>
+      </p:sp>
+      <p:sp>
+        <p:nvSpPr>
+          <p:cNvPr id="14" name="Text 10"/>
+          <p:cNvSpPr txBox="1"/>
+          <p:nvPr/>
+        </p:nvSpPr>
+        <p:spPr>
+          <a:xfrm>
+            <a:off x="731520" y="3749040"/>
+            <a:ext cx="3474720" cy="731520"/>
+          </a:xfrm>
+          <a:prstGeom prst="rect">
+            <a:avLst/>
+          </a:prstGeom>
+          <a:noFill/>
+          <a:ln/>
+        </p:spPr>
+        <p:txBody>
+          <a:bodyPr wrap="square" lIns="0" tIns="0" rIns="0" bIns="0" rtlCol="0" anchor="t"/>
+          <a:lstStyle/>
+          <a:p>
+            <a:pPr indent="0" marL="0">
+              <a:buNone/>
+            </a:pPr>
+            <a:r>
+              <a:rPr lang="en-US" sz="1300" dirty="0">
+                <a:solidFill>
+                  <a:srgbClr val="FFFFFF"/>
+                </a:solidFill>
+                <a:latin typeface="Calibri" pitchFamily="34" charset="0"/>
+                <a:ea typeface="Calibri" pitchFamily="34" charset="-122"/>
+                <a:cs typeface="Calibri" pitchFamily="34" charset="-120"/>
+              </a:rPr>
+              <a:t>Inform them the same day. No delay between the issue and the escalation.</a:t>
+            </a:r>
+            <a:endParaRPr lang="en-US" sz="1300" dirty="0"/>
+          </a:p>
+        </p:txBody>
+      </p:sp>
+      <p:sp>
+        <p:nvSpPr>
+          <p:cNvPr id="15" name="Text 11"/>
+          <p:cNvSpPr txBox="1"/>
+          <p:nvPr/>
+        </p:nvSpPr>
+        <p:spPr>
+          <a:xfrm>
+            <a:off x="4800600" y="1234440"/>
+            <a:ext cx="3886200" cy="365760"/>
+          </a:xfrm>
+          <a:prstGeom prst="rect">
+            <a:avLst/>
+          </a:prstGeom>
+          <a:noFill/>
+          <a:ln/>
+        </p:spPr>
+        <p:txBody>
+          <a:bodyPr wrap="square" lIns="0" tIns="0" rIns="0" bIns="0" rtlCol="0" anchor="ctr"/>
+          <a:lstStyle/>
+          <a:p>
+            <a:pPr indent="0" marL="0">
+              <a:buNone/>
+            </a:pPr>
+            <a:r>
+              <a:rPr lang="en-US" sz="1800" b="1" dirty="0">
+                <a:solidFill>
+                  <a:srgbClr val="2B1A22"/>
+                </a:solidFill>
+                <a:latin typeface="Arial" pitchFamily="34" charset="0"/>
+                <a:ea typeface="Arial" pitchFamily="34" charset="-122"/>
+                <a:cs typeface="Arial" pitchFamily="34" charset="-120"/>
+              </a:rPr>
+              <a:t>Handover before leave</a:t>
+            </a:r>
+            <a:endParaRPr lang="en-US" sz="1800" dirty="0"/>
+          </a:p>
+        </p:txBody>
+      </p:sp>
+      <p:sp>
+        <p:nvSpPr>
+          <p:cNvPr id="16" name="Shape 12"/>
+          <p:cNvSpPr/>
+          <p:nvPr/>
+        </p:nvSpPr>
+        <p:spPr>
+          <a:xfrm>
+            <a:off x="4800600" y="1737360"/>
+            <a:ext cx="292608" cy="292608"/>
+          </a:xfrm>
+          <a:prstGeom prst="ellipse">
+            <a:avLst/>
+          </a:prstGeom>
+          <a:solidFill>
+            <a:srgbClr val="C01F53"/>
+          </a:solidFill>
+          <a:ln w="12700">
+            <a:solidFill>
+              <a:srgbClr val="C01F53"/>
+            </a:solidFill>
+            <a:prstDash val="solid"/>
+          </a:ln>
+        </p:spPr>
+      </p:sp>
+      <p:pic>
+        <p:nvPicPr>
+          <p:cNvPr id="17" name="Image 2" descr="preencoded.png">    </p:cNvPr>
+          <p:cNvPicPr>
+            <a:picLocks noChangeAspect="1"/>
+          </p:cNvPicPr>
+          <p:nvPr/>
+        </p:nvPicPr>
+        <p:blipFill>
+          <a:blip r:embed="rId3"/>
+          <a:stretch>
+            <a:fillRect/>
+          </a:stretch>
+        </p:blipFill>
+        <p:spPr>
+          <a:xfrm>
+            <a:off x="4873752" y="1810512"/>
+            <a:ext cx="146304" cy="146304"/>
+          </a:xfrm>
+          <a:prstGeom prst="rect">
+            <a:avLst/>
+          </a:prstGeom>
+        </p:spPr>
+      </p:pic>
+      <p:sp>
+        <p:nvSpPr>
+          <p:cNvPr id="18" name="Text 13"/>
+          <p:cNvSpPr txBox="1"/>
+          <p:nvPr/>
+        </p:nvSpPr>
+        <p:spPr>
+          <a:xfrm>
+            <a:off x="5230368" y="1737360"/>
+            <a:ext cx="3474720" cy="292608"/>
+          </a:xfrm>
+          <a:prstGeom prst="rect">
+            <a:avLst/>
+          </a:prstGeom>
+          <a:noFill/>
+          <a:ln/>
+        </p:spPr>
+        <p:txBody>
+          <a:bodyPr wrap="square" lIns="0" tIns="0" rIns="0" bIns="0" rtlCol="0" anchor="ctr"/>
+          <a:lstStyle/>
+          <a:p>
+            <a:pPr indent="0" marL="0">
+              <a:buNone/>
+            </a:pPr>
+            <a:r>
+              <a:rPr lang="en-US" sz="1400" dirty="0">
+                <a:solidFill>
+                  <a:srgbClr val="2B1A22"/>
+                </a:solidFill>
+                <a:latin typeface="Calibri" pitchFamily="34" charset="0"/>
+                <a:ea typeface="Calibri" pitchFamily="34" charset="-122"/>
+                <a:cs typeface="Calibri" pitchFamily="34" charset="-120"/>
+              </a:rPr>
+              <a:t>All student document details</a:t>
+            </a:r>
+            <a:endParaRPr lang="en-US" sz="1400" dirty="0"/>
+          </a:p>
+        </p:txBody>
+      </p:sp>
+      <p:sp>
+        <p:nvSpPr>
+          <p:cNvPr id="19" name="Shape 14"/>
+          <p:cNvSpPr/>
+          <p:nvPr/>
+        </p:nvSpPr>
+        <p:spPr>
+          <a:xfrm>
+            <a:off x="4800600" y="2148840"/>
+            <a:ext cx="292608" cy="292608"/>
+          </a:xfrm>
+          <a:prstGeom prst="ellipse">
+            <a:avLst/>
+          </a:prstGeom>
+          <a:solidFill>
+            <a:srgbClr val="C01F53"/>
+          </a:solidFill>
+          <a:ln w="12700">
+            <a:solidFill>
+              <a:srgbClr val="C01F53"/>
+            </a:solidFill>
+            <a:prstDash val="solid"/>
+          </a:ln>
+        </p:spPr>
+      </p:sp>
+      <p:pic>
+        <p:nvPicPr>
+          <p:cNvPr id="20" name="Image 3" descr="preencoded.png">    </p:cNvPr>
+          <p:cNvPicPr>
+            <a:picLocks noChangeAspect="1"/>
+          </p:cNvPicPr>
+          <p:nvPr/>
+        </p:nvPicPr>
+        <p:blipFill>
+          <a:blip r:embed="rId4"/>
+          <a:stretch>
+            <a:fillRect/>
+          </a:stretch>
+        </p:blipFill>
+        <p:spPr>
+          <a:xfrm>
+            <a:off x="4873752" y="2221992"/>
+            <a:ext cx="146304" cy="146304"/>
+          </a:xfrm>
+          <a:prstGeom prst="rect">
+            <a:avLst/>
+          </a:prstGeom>
+        </p:spPr>
+      </p:pic>
+      <p:sp>
+        <p:nvSpPr>
+          <p:cNvPr id="21" name="Text 15"/>
+          <p:cNvSpPr txBox="1"/>
+          <p:nvPr/>
+        </p:nvSpPr>
+        <p:spPr>
+          <a:xfrm>
+            <a:off x="5230368" y="2148840"/>
+            <a:ext cx="3474720" cy="292608"/>
+          </a:xfrm>
+          <a:prstGeom prst="rect">
+            <a:avLst/>
+          </a:prstGeom>
+          <a:noFill/>
+          <a:ln/>
+        </p:spPr>
+        <p:txBody>
+          <a:bodyPr wrap="square" lIns="0" tIns="0" rIns="0" bIns="0" rtlCol="0" anchor="ctr"/>
+          <a:lstStyle/>
+          <a:p>
+            <a:pPr indent="0" marL="0">
+              <a:buNone/>
+            </a:pPr>
+            <a:r>
+              <a:rPr lang="en-US" sz="1400" dirty="0">
+                <a:solidFill>
+                  <a:srgbClr val="2B1A22"/>
+                </a:solidFill>
+                <a:latin typeface="Calibri" pitchFamily="34" charset="0"/>
+                <a:ea typeface="Calibri" pitchFamily="34" charset="-122"/>
+                <a:cs typeface="Calibri" pitchFamily="34" charset="-120"/>
+              </a:rPr>
+              <a:t>Current status of each file</a:t>
+            </a:r>
+            <a:endParaRPr lang="en-US" sz="1400" dirty="0"/>
+          </a:p>
+        </p:txBody>
+      </p:sp>
+      <p:sp>
+        <p:nvSpPr>
+          <p:cNvPr id="22" name="Shape 16"/>
+          <p:cNvSpPr/>
+          <p:nvPr/>
+        </p:nvSpPr>
+        <p:spPr>
+          <a:xfrm>
+            <a:off x="4800600" y="2560320"/>
+            <a:ext cx="292608" cy="292608"/>
+          </a:xfrm>
+          <a:prstGeom prst="ellipse">
+            <a:avLst/>
+          </a:prstGeom>
+          <a:solidFill>
+            <a:srgbClr val="C01F53"/>
+          </a:solidFill>
+          <a:ln w="12700">
+            <a:solidFill>
+              <a:srgbClr val="C01F53"/>
+            </a:solidFill>
+            <a:prstDash val="solid"/>
+          </a:ln>
+        </p:spPr>
+      </p:sp>
+      <p:pic>
+        <p:nvPicPr>
+          <p:cNvPr id="23" name="Image 4" descr="preencoded.png">    </p:cNvPr>
+          <p:cNvPicPr>
+            <a:picLocks noChangeAspect="1"/>
+          </p:cNvPicPr>
+          <p:nvPr/>
+        </p:nvPicPr>
+        <p:blipFill>
+          <a:blip r:embed="rId5"/>
+          <a:stretch>
+            <a:fillRect/>
+          </a:stretch>
+        </p:blipFill>
+        <p:spPr>
+          <a:xfrm>
+            <a:off x="4873752" y="2633472"/>
+            <a:ext cx="146304" cy="146304"/>
+          </a:xfrm>
+          <a:prstGeom prst="rect">
+            <a:avLst/>
+          </a:prstGeom>
+        </p:spPr>
+      </p:pic>
+      <p:sp>
+        <p:nvSpPr>
+          <p:cNvPr id="24" name="Text 17"/>
+          <p:cNvSpPr txBox="1"/>
+          <p:nvPr/>
+        </p:nvSpPr>
+        <p:spPr>
+          <a:xfrm>
+            <a:off x="5230368" y="2560320"/>
+            <a:ext cx="3474720" cy="292608"/>
+          </a:xfrm>
+          <a:prstGeom prst="rect">
+            <a:avLst/>
+          </a:prstGeom>
+          <a:noFill/>
+          <a:ln/>
+        </p:spPr>
+        <p:txBody>
+          <a:bodyPr wrap="square" lIns="0" tIns="0" rIns="0" bIns="0" rtlCol="0" anchor="ctr"/>
+          <a:lstStyle/>
+          <a:p>
+            <a:pPr indent="0" marL="0">
+              <a:buNone/>
+            </a:pPr>
+            <a:r>
+              <a:rPr lang="en-US" sz="1400" dirty="0">
+                <a:solidFill>
+                  <a:srgbClr val="2B1A22"/>
+                </a:solidFill>
+                <a:latin typeface="Calibri" pitchFamily="34" charset="0"/>
+                <a:ea typeface="Calibri" pitchFamily="34" charset="-122"/>
+                <a:cs typeface="Calibri" pitchFamily="34" charset="-120"/>
+              </a:rPr>
+              <a:t>Pending documents &amp; payments</a:t>
+            </a:r>
+            <a:endParaRPr lang="en-US" sz="1400" dirty="0"/>
+          </a:p>
+        </p:txBody>
+      </p:sp>
+      <p:sp>
+        <p:nvSpPr>
+          <p:cNvPr id="25" name="Shape 18"/>
+          <p:cNvSpPr/>
+          <p:nvPr/>
+        </p:nvSpPr>
+        <p:spPr>
+          <a:xfrm>
+            <a:off x="4800600" y="2971800"/>
+            <a:ext cx="292608" cy="292608"/>
+          </a:xfrm>
+          <a:prstGeom prst="ellipse">
+            <a:avLst/>
+          </a:prstGeom>
+          <a:solidFill>
+            <a:srgbClr val="C01F53"/>
+          </a:solidFill>
+          <a:ln w="12700">
+            <a:solidFill>
+              <a:srgbClr val="C01F53"/>
+            </a:solidFill>
+            <a:prstDash val="solid"/>
+          </a:ln>
+        </p:spPr>
+      </p:sp>
+      <p:pic>
+        <p:nvPicPr>
+          <p:cNvPr id="26" name="Image 5" descr="preencoded.png">    </p:cNvPr>
+          <p:cNvPicPr>
+            <a:picLocks noChangeAspect="1"/>
+          </p:cNvPicPr>
+          <p:nvPr/>
+        </p:nvPicPr>
+        <p:blipFill>
+          <a:blip r:embed="rId6"/>
+          <a:stretch>
+            <a:fillRect/>
+          </a:stretch>
+        </p:blipFill>
+        <p:spPr>
+          <a:xfrm>
+            <a:off x="4873752" y="3044952"/>
+            <a:ext cx="146304" cy="146304"/>
+          </a:xfrm>
+          <a:prstGeom prst="rect">
+            <a:avLst/>
+          </a:prstGeom>
+        </p:spPr>
+      </p:pic>
+      <p:sp>
+        <p:nvSpPr>
+          <p:cNvPr id="27" name="Text 19"/>
+          <p:cNvSpPr txBox="1"/>
+          <p:nvPr/>
+        </p:nvSpPr>
+        <p:spPr>
+          <a:xfrm>
+            <a:off x="5230368" y="2971800"/>
+            <a:ext cx="3474720" cy="292608"/>
+          </a:xfrm>
+          <a:prstGeom prst="rect">
+            <a:avLst/>
+          </a:prstGeom>
+          <a:noFill/>
+          <a:ln/>
+        </p:spPr>
+        <p:txBody>
+          <a:bodyPr wrap="square" lIns="0" tIns="0" rIns="0" bIns="0" rtlCol="0" anchor="ctr"/>
+          <a:lstStyle/>
+          <a:p>
+            <a:pPr indent="0" marL="0">
+              <a:buNone/>
+            </a:pPr>
+            <a:r>
+              <a:rPr lang="en-US" sz="1400" dirty="0">
+                <a:solidFill>
+                  <a:srgbClr val="2B1A22"/>
+                </a:solidFill>
+                <a:latin typeface="Calibri" pitchFamily="34" charset="0"/>
+                <a:ea typeface="Calibri" pitchFamily="34" charset="-122"/>
+                <a:cs typeface="Calibri" pitchFamily="34" charset="-120"/>
+              </a:rPr>
+              <a:t>Open escalations &amp; next steps</a:t>
+            </a:r>
+            <a:endParaRPr lang="en-US" sz="1400" dirty="0"/>
+          </a:p>
+        </p:txBody>
+      </p:sp>
+      <p:sp>
+        <p:nvSpPr>
+          <p:cNvPr id="28" name="Shape 20"/>
+          <p:cNvSpPr/>
+          <p:nvPr/>
+        </p:nvSpPr>
+        <p:spPr>
+          <a:xfrm>
+            <a:off x="4800600" y="3383280"/>
+            <a:ext cx="292608" cy="292608"/>
+          </a:xfrm>
+          <a:prstGeom prst="ellipse">
+            <a:avLst/>
+          </a:prstGeom>
+          <a:solidFill>
+            <a:srgbClr val="C01F53"/>
+          </a:solidFill>
+          <a:ln w="12700">
+            <a:solidFill>
+              <a:srgbClr val="C01F53"/>
+            </a:solidFill>
+            <a:prstDash val="solid"/>
+          </a:ln>
+        </p:spPr>
+      </p:sp>
+      <p:pic>
+        <p:nvPicPr>
+          <p:cNvPr id="29" name="Image 6" descr="preencoded.png">    </p:cNvPr>
+          <p:cNvPicPr>
+            <a:picLocks noChangeAspect="1"/>
+          </p:cNvPicPr>
+          <p:nvPr/>
+        </p:nvPicPr>
+        <p:blipFill>
+          <a:blip r:embed="rId7"/>
+          <a:stretch>
+            <a:fillRect/>
+          </a:stretch>
+        </p:blipFill>
+        <p:spPr>
+          <a:xfrm>
+            <a:off x="4873752" y="3456432"/>
+            <a:ext cx="146304" cy="146304"/>
+          </a:xfrm>
+          <a:prstGeom prst="rect">
+            <a:avLst/>
+          </a:prstGeom>
+        </p:spPr>
+      </p:pic>
+      <p:sp>
+        <p:nvSpPr>
+          <p:cNvPr id="30" name="Text 21"/>
+          <p:cNvSpPr txBox="1"/>
+          <p:nvPr/>
+        </p:nvSpPr>
+        <p:spPr>
+          <a:xfrm>
+            <a:off x="5230368" y="3383280"/>
+            <a:ext cx="3474720" cy="292608"/>
+          </a:xfrm>
+          <a:prstGeom prst="rect">
+            <a:avLst/>
+          </a:prstGeom>
+          <a:noFill/>
+          <a:ln/>
+        </p:spPr>
+        <p:txBody>
+          <a:bodyPr wrap="square" lIns="0" tIns="0" rIns="0" bIns="0" rtlCol="0" anchor="ctr"/>
+          <a:lstStyle/>
+          <a:p>
+            <a:pPr indent="0" marL="0">
+              <a:buNone/>
+            </a:pPr>
+            <a:r>
+              <a:rPr lang="en-US" sz="1400" dirty="0">
+                <a:solidFill>
+                  <a:srgbClr val="2B1A22"/>
+                </a:solidFill>
+                <a:latin typeface="Calibri" pitchFamily="34" charset="0"/>
+                <a:ea typeface="Calibri" pitchFamily="34" charset="-122"/>
+                <a:cs typeface="Calibri" pitchFamily="34" charset="-120"/>
+              </a:rPr>
+              <a:t>WhatsApp groups &amp; contacts</a:t>
+            </a:r>
+            <a:endParaRPr lang="en-US" sz="1400" dirty="0"/>
+          </a:p>
+        </p:txBody>
+      </p:sp>
+      <p:sp>
+        <p:nvSpPr>
+          <p:cNvPr id="31" name="Shape 22"/>
+          <p:cNvSpPr/>
+          <p:nvPr/>
+        </p:nvSpPr>
+        <p:spPr>
+          <a:xfrm>
+            <a:off x="4800600" y="3931920"/>
+            <a:ext cx="3886200" cy="731520"/>
+          </a:xfrm>
+          <a:prstGeom prst="roundRect">
+            <a:avLst>
+              <a:gd name="adj" fmla="val 15000"/>
+            </a:avLst>
+          </a:prstGeom>
+          <a:solidFill>
+            <a:srgbClr val="FFFBD6"/>
+          </a:solidFill>
+          <a:ln w="9525">
+            <a:solidFill>
+              <a:srgbClr val="EBD3DC"/>
+            </a:solidFill>
+            <a:prstDash val="solid"/>
+          </a:ln>
+          <a:effectLst>
+            <a:outerShdw sx="100000" sy="100000" kx="0" ky="0" algn="bl" rotWithShape="0" blurRad="76200" dist="25400" dir="5400000">
+              <a:srgbClr val="000000">
+                <a:alpha val="12000"/>
+              </a:srgbClr>
+            </a:outerShdw>
+          </a:effectLst>
+        </p:spPr>
+      </p:sp>
+      <p:sp>
+        <p:nvSpPr>
+          <p:cNvPr id="32" name="Shape 23"/>
+          <p:cNvSpPr/>
+          <p:nvPr/>
+        </p:nvSpPr>
+        <p:spPr>
+          <a:xfrm>
+            <a:off x="4937760" y="4059936"/>
+            <a:ext cx="475488" cy="475488"/>
+          </a:xfrm>
+          <a:prstGeom prst="ellipse">
+            <a:avLst/>
+          </a:prstGeom>
+          <a:solidFill>
+            <a:srgbClr val="EDE72D"/>
+          </a:solidFill>
+          <a:ln w="12700">
+            <a:solidFill>
+              <a:srgbClr val="EDE72D"/>
+            </a:solidFill>
+            <a:prstDash val="solid"/>
+          </a:ln>
+        </p:spPr>
+      </p:sp>
+      <p:pic>
+        <p:nvPicPr>
+          <p:cNvPr id="33" name="Image 7" descr="preencoded.png">    </p:cNvPr>
+          <p:cNvPicPr>
+            <a:picLocks noChangeAspect="1"/>
+          </p:cNvPicPr>
+          <p:nvPr/>
+        </p:nvPicPr>
+        <p:blipFill>
+          <a:blip r:embed="rId8"/>
+          <a:stretch>
+            <a:fillRect/>
+          </a:stretch>
+        </p:blipFill>
+        <p:spPr>
+          <a:xfrm>
+            <a:off x="5056632" y="4178808"/>
+            <a:ext cx="237744" cy="237744"/>
+          </a:xfrm>
+          <a:prstGeom prst="rect">
+            <a:avLst/>
+          </a:prstGeom>
+        </p:spPr>
+      </p:pic>
+      <p:sp>
+        <p:nvSpPr>
+          <p:cNvPr id="34" name="Text 24"/>
+          <p:cNvSpPr txBox="1"/>
+          <p:nvPr/>
+        </p:nvSpPr>
+        <p:spPr>
+          <a:xfrm>
+            <a:off x="5532120" y="3931920"/>
+            <a:ext cx="3063240" cy="731520"/>
+          </a:xfrm>
+          <a:prstGeom prst="rect">
+            <a:avLst/>
+          </a:prstGeom>
+          <a:noFill/>
+          <a:ln/>
+        </p:spPr>
+        <p:txBody>
+          <a:bodyPr wrap="square" lIns="0" tIns="0" rIns="0" bIns="0" rtlCol="0" anchor="ctr"/>
+          <a:lstStyle/>
+          <a:p>
+            <a:pPr indent="0" marL="0">
+              <a:buNone/>
+            </a:pPr>
+            <a:r>
+              <a:rPr lang="en-US" sz="1400" b="1" dirty="0">
+                <a:solidFill>
+                  <a:srgbClr val="2B1A22"/>
+                </a:solidFill>
+                <a:latin typeface="Arial" pitchFamily="34" charset="0"/>
+                <a:ea typeface="Arial" pitchFamily="34" charset="-122"/>
+                <a:cs typeface="Arial" pitchFamily="34" charset="-120"/>
+              </a:rPr>
+              <a:t>No complete handover = no leave.</a:t>
+            </a:r>
+            <a:endParaRPr lang="en-US" sz="1400" dirty="0"/>
+          </a:p>
+        </p:txBody>
+      </p:sp>
+    </p:spTree>
+  </p:cSld>
+  <p:clrMapOvr>
+    <a:masterClrMapping/>
+  </p:clrMapOvr>
+</p:sld>
+</file>
+
+<file path=ppt/slides/slide11.xml><?xml version="1.0" encoding="utf-8"?>
+<p:sld xmlns:a="http://schemas.openxmlformats.org/drawingml/2006/main" xmlns:r="http://schemas.openxmlformats.org/officeDocument/2006/relationships" xmlns:p="http://schemas.openxmlformats.org/presentationml/2006/main">
+  <p:cSld name="Slide 11">
+    <p:bg>
+      <p:bgPr>
+        <a:solidFill>
+          <a:srgbClr val="FFFFFF"/>
+        </a:solidFill>
+      </p:bgPr>
+    </p:bg>
+    <p:spTree>
+      <p:nvGrpSpPr>
+        <p:cNvPr id="1" name=""/>
+        <p:cNvGrpSpPr/>
+        <p:nvPr/>
+      </p:nvGrpSpPr>
+      <p:grpSpPr>
+        <a:xfrm>
+          <a:off x="0" y="0"/>
+          <a:ext cx="0" cy="0"/>
+          <a:chOff x="0" y="0"/>
+          <a:chExt cx="0" cy="0"/>
+        </a:xfrm>
+      </p:grpSpPr>
+      <p:sp>
+        <p:nvSpPr>
+          <p:cNvPr id="2" name="Text 0"/>
+          <p:cNvSpPr txBox="1"/>
+          <p:nvPr/>
+        </p:nvSpPr>
+        <p:spPr>
+          <a:xfrm>
+            <a:off x="457200" y="274320"/>
+            <a:ext cx="6492240" cy="457200"/>
+          </a:xfrm>
+          <a:prstGeom prst="rect">
+            <a:avLst/>
+          </a:prstGeom>
+          <a:noFill/>
+          <a:ln/>
+        </p:spPr>
+        <p:txBody>
+          <a:bodyPr wrap="square" lIns="0" tIns="0" rIns="0" bIns="0" rtlCol="0" anchor="ctr"/>
+          <a:lstStyle/>
+          <a:p>
+            <a:pPr indent="0" marL="0">
+              <a:buNone/>
+            </a:pPr>
+            <a:r>
+              <a:rPr lang="en-US" sz="2600" b="1" dirty="0">
+                <a:solidFill>
+                  <a:srgbClr val="2B1A22"/>
+                </a:solidFill>
+                <a:latin typeface="Arial" pitchFamily="34" charset="0"/>
+                <a:ea typeface="Arial" pitchFamily="34" charset="-122"/>
+                <a:cs typeface="Arial" pitchFamily="34" charset="-120"/>
+              </a:rPr>
+              <a:t>Who Owns What</a:t>
+            </a:r>
+            <a:endParaRPr lang="en-US" sz="2600" dirty="0"/>
+          </a:p>
+        </p:txBody>
+      </p:sp>
+      <p:sp>
+        <p:nvSpPr>
+          <p:cNvPr id="3" name="Text 1"/>
+          <p:cNvSpPr txBox="1"/>
+          <p:nvPr/>
+        </p:nvSpPr>
+        <p:spPr>
+          <a:xfrm>
+            <a:off x="457200" y="713232"/>
+            <a:ext cx="6675120" cy="274320"/>
+          </a:xfrm>
+          <a:prstGeom prst="rect">
+            <a:avLst/>
+          </a:prstGeom>
+          <a:noFill/>
+          <a:ln/>
+        </p:spPr>
+        <p:txBody>
+          <a:bodyPr wrap="square" lIns="0" tIns="0" rIns="0" bIns="0" rtlCol="0" anchor="ctr"/>
+          <a:lstStyle/>
+          <a:p>
+            <a:pPr indent="0" marL="0">
+              <a:buNone/>
+            </a:pPr>
+            <a:r>
+              <a:rPr lang="en-US" sz="1300" i="1" dirty="0">
+                <a:solidFill>
+                  <a:srgbClr val="C01F53"/>
+                </a:solidFill>
+                <a:latin typeface="Calibri" pitchFamily="34" charset="0"/>
+                <a:ea typeface="Calibri" pitchFamily="34" charset="-122"/>
+                <a:cs typeface="Calibri" pitchFamily="34" charset="-120"/>
+              </a:rPr>
+              <a:t>Clear ownership keeps every file moving</a:t>
+            </a:r>
+            <a:endParaRPr lang="en-US" sz="1300" dirty="0"/>
+          </a:p>
+        </p:txBody>
+      </p:sp>
+      <p:pic>
+        <p:nvPicPr>
+          <p:cNvPr id="4" name="Image 0" descr="preencoded.png">    </p:cNvPr>
+          <p:cNvPicPr>
+            <a:picLocks noChangeAspect="1"/>
+          </p:cNvPicPr>
+          <p:nvPr/>
+        </p:nvPicPr>
+        <p:blipFill>
+          <a:blip r:embed="rId1"/>
+          <a:stretch>
+            <a:fillRect/>
+          </a:stretch>
+        </p:blipFill>
+        <p:spPr>
+          <a:xfrm>
+            <a:off x="8183880" y="274320"/>
+            <a:ext cx="548640" cy="548640"/>
+          </a:xfrm>
+          <a:prstGeom prst="rect">
+            <a:avLst/>
+          </a:prstGeom>
+        </p:spPr>
+      </p:pic>
       <p:graphicFrame>
         <p:nvGraphicFramePr>
-          <p:cNvPr id="11" name="Table 0"/>
+          <p:cNvPr id="12" name="Table 0"/>
           <p:cNvGraphicFramePr>
             <a:graphicFrameLocks noGrp="1"/>
           </p:cNvGraphicFramePr>
@@ -3237,9 +4681,9 @@
 </p:sld>
 </file>
 
-<file path=ppt/slides/slide11.xml><?xml version="1.0" encoding="utf-8"?>
+<file path=ppt/slides/slide12.xml><?xml version="1.0" encoding="utf-8"?>
 <p:sld xmlns:a="http://schemas.openxmlformats.org/drawingml/2006/main" xmlns:r="http://schemas.openxmlformats.org/officeDocument/2006/relationships" xmlns:p="http://schemas.openxmlformats.org/presentationml/2006/main">
-  <p:cSld name="Slide 11">
+  <p:cSld name="Slide 12">
     <p:bg>
       <p:bgPr>
         <a:solidFill>
@@ -4298,9 +5742,1935 @@
 </p:sld>
 </file>
 
-<file path=ppt/slides/slide12.xml><?xml version="1.0" encoding="utf-8"?>
+<file path=ppt/slides/slide13.xml><?xml version="1.0" encoding="utf-8"?>
 <p:sld xmlns:a="http://schemas.openxmlformats.org/drawingml/2006/main" xmlns:r="http://schemas.openxmlformats.org/officeDocument/2006/relationships" xmlns:p="http://schemas.openxmlformats.org/presentationml/2006/main">
-  <p:cSld name="Slide 12">
+  <p:cSld name="Slide 13">
+    <p:bg>
+      <p:bgPr>
+        <a:solidFill>
+          <a:srgbClr val="C01F53"/>
+        </a:solidFill>
+      </p:bgPr>
+    </p:bg>
+    <p:spTree>
+      <p:nvGrpSpPr>
+        <p:cNvPr id="1" name=""/>
+        <p:cNvGrpSpPr/>
+        <p:nvPr/>
+      </p:nvGrpSpPr>
+      <p:grpSpPr>
+        <a:xfrm>
+          <a:off x="0" y="0"/>
+          <a:ext cx="0" cy="0"/>
+          <a:chOff x="0" y="0"/>
+          <a:chExt cx="0" cy="0"/>
+        </a:xfrm>
+      </p:grpSpPr>
+      <p:sp>
+        <p:nvSpPr>
+          <p:cNvPr id="2" name="Shape 0"/>
+          <p:cNvSpPr/>
+          <p:nvPr/>
+        </p:nvSpPr>
+        <p:spPr>
+          <a:xfrm>
+            <a:off x="548640" y="1143000"/>
+            <a:ext cx="822960" cy="822960"/>
+          </a:xfrm>
+          <a:prstGeom prst="ellipse">
+            <a:avLst/>
+          </a:prstGeom>
+          <a:solidFill>
+            <a:srgbClr val="EDE72D"/>
+          </a:solidFill>
+          <a:ln w="12700">
+            <a:solidFill>
+              <a:srgbClr val="EDE72D"/>
+            </a:solidFill>
+            <a:prstDash val="solid"/>
+          </a:ln>
+        </p:spPr>
+      </p:sp>
+      <p:pic>
+        <p:nvPicPr>
+          <p:cNvPr id="3" name="Image 0" descr="preencoded.png">    </p:cNvPr>
+          <p:cNvPicPr>
+            <a:picLocks noChangeAspect="1"/>
+          </p:cNvPicPr>
+          <p:nvPr/>
+        </p:nvPicPr>
+        <p:blipFill>
+          <a:blip r:embed="rId1"/>
+          <a:stretch>
+            <a:fillRect/>
+          </a:stretch>
+        </p:blipFill>
+        <p:spPr>
+          <a:xfrm>
+            <a:off x="754380" y="1348740"/>
+            <a:ext cx="411480" cy="411480"/>
+          </a:xfrm>
+          <a:prstGeom prst="rect">
+            <a:avLst/>
+          </a:prstGeom>
+        </p:spPr>
+      </p:pic>
+      <p:sp>
+        <p:nvSpPr>
+          <p:cNvPr id="4" name="Text 1"/>
+          <p:cNvSpPr txBox="1"/>
+          <p:nvPr/>
+        </p:nvSpPr>
+        <p:spPr>
+          <a:xfrm>
+            <a:off x="548640" y="2148840"/>
+            <a:ext cx="5486400" cy="365760"/>
+          </a:xfrm>
+          <a:prstGeom prst="rect">
+            <a:avLst/>
+          </a:prstGeom>
+          <a:noFill/>
+          <a:ln/>
+        </p:spPr>
+        <p:txBody>
+          <a:bodyPr wrap="square" lIns="0" tIns="0" rIns="0" bIns="0" rtlCol="0" anchor="ctr"/>
+          <a:lstStyle/>
+          <a:p>
+            <a:pPr indent="0" marL="0">
+              <a:buNone/>
+            </a:pPr>
+            <a:r>
+              <a:rPr lang="en-US" sz="1400" b="1" spc="400" kern="0" dirty="0">
+                <a:solidFill>
+                  <a:srgbClr val="EDE72D"/>
+                </a:solidFill>
+                <a:latin typeface="Arial" pitchFamily="34" charset="0"/>
+                <a:ea typeface="Arial" pitchFamily="34" charset="-122"/>
+                <a:cs typeface="Arial" pitchFamily="34" charset="-120"/>
+              </a:rPr>
+              <a:t>PART 2</a:t>
+            </a:r>
+            <a:endParaRPr lang="en-US" sz="1400" dirty="0"/>
+          </a:p>
+        </p:txBody>
+      </p:sp>
+      <p:sp>
+        <p:nvSpPr>
+          <p:cNvPr id="5" name="Text 2"/>
+          <p:cNvSpPr txBox="1"/>
+          <p:nvPr/>
+        </p:nvSpPr>
+        <p:spPr>
+          <a:xfrm>
+            <a:off x="548640" y="2514600"/>
+            <a:ext cx="5943600" cy="685800"/>
+          </a:xfrm>
+          <a:prstGeom prst="rect">
+            <a:avLst/>
+          </a:prstGeom>
+          <a:noFill/>
+          <a:ln/>
+        </p:spPr>
+        <p:txBody>
+          <a:bodyPr wrap="square" lIns="0" tIns="0" rIns="0" bIns="0" rtlCol="0" anchor="ctr"/>
+          <a:lstStyle/>
+          <a:p>
+            <a:pPr indent="0" marL="0">
+              <a:buNone/>
+            </a:pPr>
+            <a:r>
+              <a:rPr lang="en-US" sz="3400" b="1" dirty="0">
+                <a:solidFill>
+                  <a:srgbClr val="FFFFFF"/>
+                </a:solidFill>
+                <a:latin typeface="Arial" pitchFamily="34" charset="0"/>
+                <a:ea typeface="Arial" pitchFamily="34" charset="-122"/>
+                <a:cs typeface="Arial" pitchFamily="34" charset="-120"/>
+              </a:rPr>
+              <a:t>Study Abroad Refund Policy</a:t>
+            </a:r>
+            <a:endParaRPr lang="en-US" sz="3400" dirty="0"/>
+          </a:p>
+        </p:txBody>
+      </p:sp>
+      <p:sp>
+        <p:nvSpPr>
+          <p:cNvPr id="6" name="Text 3"/>
+          <p:cNvSpPr txBox="1"/>
+          <p:nvPr/>
+        </p:nvSpPr>
+        <p:spPr>
+          <a:xfrm>
+            <a:off x="548640" y="3291840"/>
+            <a:ext cx="5303520" cy="731520"/>
+          </a:xfrm>
+          <a:prstGeom prst="rect">
+            <a:avLst/>
+          </a:prstGeom>
+          <a:noFill/>
+          <a:ln/>
+        </p:spPr>
+        <p:txBody>
+          <a:bodyPr wrap="square" lIns="0" tIns="0" rIns="0" bIns="0" rtlCol="0" anchor="t"/>
+          <a:lstStyle/>
+          <a:p>
+            <a:pPr indent="0" marL="0">
+              <a:buNone/>
+            </a:pPr>
+            <a:r>
+              <a:rPr lang="en-US" sz="1500" dirty="0">
+                <a:solidFill>
+                  <a:srgbClr val="FFFFFF"/>
+                </a:solidFill>
+                <a:latin typeface="Calibri" pitchFamily="34" charset="0"/>
+                <a:ea typeface="Calibri" pitchFamily="34" charset="-122"/>
+                <a:cs typeface="Calibri" pitchFamily="34" charset="-120"/>
+              </a:rPr>
+              <a:t>Every refund request is documented, verified and approved through one clear workflow. Effective immediately.</a:t>
+            </a:r>
+            <a:endParaRPr lang="en-US" sz="1500" dirty="0"/>
+          </a:p>
+        </p:txBody>
+      </p:sp>
+      <p:pic>
+        <p:nvPicPr>
+          <p:cNvPr id="7" name="Image 1" descr="preencoded.png">    </p:cNvPr>
+          <p:cNvPicPr>
+            <a:picLocks noChangeAspect="1"/>
+          </p:cNvPicPr>
+          <p:nvPr/>
+        </p:nvPicPr>
+        <p:blipFill>
+          <a:blip r:embed="rId2"/>
+          <a:stretch>
+            <a:fillRect/>
+          </a:stretch>
+        </p:blipFill>
+        <p:spPr>
+          <a:xfrm>
+            <a:off x="6675120" y="1280160"/>
+            <a:ext cx="2011680" cy="2011680"/>
+          </a:xfrm>
+          <a:prstGeom prst="rect">
+            <a:avLst/>
+          </a:prstGeom>
+        </p:spPr>
+      </p:pic>
+    </p:spTree>
+  </p:cSld>
+  <p:clrMapOvr>
+    <a:masterClrMapping/>
+  </p:clrMapOvr>
+</p:sld>
+</file>
+
+<file path=ppt/slides/slide14.xml><?xml version="1.0" encoding="utf-8"?>
+<p:sld xmlns:a="http://schemas.openxmlformats.org/drawingml/2006/main" xmlns:r="http://schemas.openxmlformats.org/officeDocument/2006/relationships" xmlns:p="http://schemas.openxmlformats.org/presentationml/2006/main">
+  <p:cSld name="Slide 14">
+    <p:bg>
+      <p:bgPr>
+        <a:solidFill>
+          <a:srgbClr val="FFFFFF"/>
+        </a:solidFill>
+      </p:bgPr>
+    </p:bg>
+    <p:spTree>
+      <p:nvGrpSpPr>
+        <p:cNvPr id="1" name=""/>
+        <p:cNvGrpSpPr/>
+        <p:nvPr/>
+      </p:nvGrpSpPr>
+      <p:grpSpPr>
+        <a:xfrm>
+          <a:off x="0" y="0"/>
+          <a:ext cx="0" cy="0"/>
+          <a:chOff x="0" y="0"/>
+          <a:chExt cx="0" cy="0"/>
+        </a:xfrm>
+      </p:grpSpPr>
+      <p:sp>
+        <p:nvSpPr>
+          <p:cNvPr id="2" name="Text 0"/>
+          <p:cNvSpPr txBox="1"/>
+          <p:nvPr/>
+        </p:nvSpPr>
+        <p:spPr>
+          <a:xfrm>
+            <a:off x="457200" y="274320"/>
+            <a:ext cx="6492240" cy="457200"/>
+          </a:xfrm>
+          <a:prstGeom prst="rect">
+            <a:avLst/>
+          </a:prstGeom>
+          <a:noFill/>
+          <a:ln/>
+        </p:spPr>
+        <p:txBody>
+          <a:bodyPr wrap="square" lIns="0" tIns="0" rIns="0" bIns="0" rtlCol="0" anchor="ctr"/>
+          <a:lstStyle/>
+          <a:p>
+            <a:pPr indent="0" marL="0">
+              <a:buNone/>
+            </a:pPr>
+            <a:r>
+              <a:rPr lang="en-US" sz="2600" b="1" dirty="0">
+                <a:solidFill>
+                  <a:srgbClr val="2B1A22"/>
+                </a:solidFill>
+                <a:latin typeface="Arial" pitchFamily="34" charset="0"/>
+                <a:ea typeface="Arial" pitchFamily="34" charset="-122"/>
+                <a:cs typeface="Arial" pitchFamily="34" charset="-120"/>
+              </a:rPr>
+              <a:t>Refund Request Workflow</a:t>
+            </a:r>
+            <a:endParaRPr lang="en-US" sz="2600" dirty="0"/>
+          </a:p>
+        </p:txBody>
+      </p:sp>
+      <p:sp>
+        <p:nvSpPr>
+          <p:cNvPr id="3" name="Text 1"/>
+          <p:cNvSpPr txBox="1"/>
+          <p:nvPr/>
+        </p:nvSpPr>
+        <p:spPr>
+          <a:xfrm>
+            <a:off x="457200" y="713232"/>
+            <a:ext cx="6675120" cy="274320"/>
+          </a:xfrm>
+          <a:prstGeom prst="rect">
+            <a:avLst/>
+          </a:prstGeom>
+          <a:noFill/>
+          <a:ln/>
+        </p:spPr>
+        <p:txBody>
+          <a:bodyPr wrap="square" lIns="0" tIns="0" rIns="0" bIns="0" rtlCol="0" anchor="ctr"/>
+          <a:lstStyle/>
+          <a:p>
+            <a:pPr indent="0" marL="0">
+              <a:buNone/>
+            </a:pPr>
+            <a:r>
+              <a:rPr lang="en-US" sz="1300" i="1" dirty="0">
+                <a:solidFill>
+                  <a:srgbClr val="C01F53"/>
+                </a:solidFill>
+                <a:latin typeface="Calibri" pitchFamily="34" charset="0"/>
+                <a:ea typeface="Calibri" pitchFamily="34" charset="-122"/>
+                <a:cs typeface="Calibri" pitchFamily="34" charset="-120"/>
+              </a:rPr>
+              <a:t>Four steps — no step can be skipped</a:t>
+            </a:r>
+            <a:endParaRPr lang="en-US" sz="1300" dirty="0"/>
+          </a:p>
+        </p:txBody>
+      </p:sp>
+      <p:pic>
+        <p:nvPicPr>
+          <p:cNvPr id="4" name="Image 0" descr="preencoded.png">    </p:cNvPr>
+          <p:cNvPicPr>
+            <a:picLocks noChangeAspect="1"/>
+          </p:cNvPicPr>
+          <p:nvPr/>
+        </p:nvPicPr>
+        <p:blipFill>
+          <a:blip r:embed="rId1"/>
+          <a:stretch>
+            <a:fillRect/>
+          </a:stretch>
+        </p:blipFill>
+        <p:spPr>
+          <a:xfrm>
+            <a:off x="8183880" y="274320"/>
+            <a:ext cx="548640" cy="548640"/>
+          </a:xfrm>
+          <a:prstGeom prst="rect">
+            <a:avLst/>
+          </a:prstGeom>
+        </p:spPr>
+      </p:pic>
+      <p:sp>
+        <p:nvSpPr>
+          <p:cNvPr id="5" name="Shape 2"/>
+          <p:cNvSpPr/>
+          <p:nvPr/>
+        </p:nvSpPr>
+        <p:spPr>
+          <a:xfrm>
+            <a:off x="457200" y="1280160"/>
+            <a:ext cx="1874520" cy="2743200"/>
+          </a:xfrm>
+          <a:prstGeom prst="roundRect">
+            <a:avLst>
+              <a:gd name="adj" fmla="val 5854"/>
+            </a:avLst>
+          </a:prstGeom>
+          <a:solidFill>
+            <a:srgbClr val="FFFFFF"/>
+          </a:solidFill>
+          <a:ln w="9525">
+            <a:solidFill>
+              <a:srgbClr val="EBD3DC"/>
+            </a:solidFill>
+            <a:prstDash val="solid"/>
+          </a:ln>
+          <a:effectLst>
+            <a:outerShdw sx="100000" sy="100000" kx="0" ky="0" algn="bl" rotWithShape="0" blurRad="76200" dist="25400" dir="5400000">
+              <a:srgbClr val="000000">
+                <a:alpha val="12000"/>
+              </a:srgbClr>
+            </a:outerShdw>
+          </a:effectLst>
+        </p:spPr>
+      </p:sp>
+      <p:sp>
+        <p:nvSpPr>
+          <p:cNvPr id="6" name="Shape 3"/>
+          <p:cNvSpPr/>
+          <p:nvPr/>
+        </p:nvSpPr>
+        <p:spPr>
+          <a:xfrm>
+            <a:off x="640080" y="1463040"/>
+            <a:ext cx="548640" cy="548640"/>
+          </a:xfrm>
+          <a:prstGeom prst="ellipse">
+            <a:avLst/>
+          </a:prstGeom>
+          <a:solidFill>
+            <a:srgbClr val="C01F53"/>
+          </a:solidFill>
+          <a:ln w="12700">
+            <a:solidFill>
+              <a:srgbClr val="C01F53"/>
+            </a:solidFill>
+            <a:prstDash val="solid"/>
+          </a:ln>
+        </p:spPr>
+      </p:sp>
+      <p:pic>
+        <p:nvPicPr>
+          <p:cNvPr id="7" name="Image 1" descr="preencoded.png">    </p:cNvPr>
+          <p:cNvPicPr>
+            <a:picLocks noChangeAspect="1"/>
+          </p:cNvPicPr>
+          <p:nvPr/>
+        </p:nvPicPr>
+        <p:blipFill>
+          <a:blip r:embed="rId2"/>
+          <a:stretch>
+            <a:fillRect/>
+          </a:stretch>
+        </p:blipFill>
+        <p:spPr>
+          <a:xfrm>
+            <a:off x="777240" y="1600200"/>
+            <a:ext cx="274320" cy="274320"/>
+          </a:xfrm>
+          <a:prstGeom prst="rect">
+            <a:avLst/>
+          </a:prstGeom>
+        </p:spPr>
+      </p:pic>
+      <p:sp>
+        <p:nvSpPr>
+          <p:cNvPr id="8" name="Text 4"/>
+          <p:cNvSpPr txBox="1"/>
+          <p:nvPr/>
+        </p:nvSpPr>
+        <p:spPr>
+          <a:xfrm>
+            <a:off x="1645920" y="1463040"/>
+            <a:ext cx="548640" cy="457200"/>
+          </a:xfrm>
+          <a:prstGeom prst="rect">
+            <a:avLst/>
+          </a:prstGeom>
+          <a:noFill/>
+          <a:ln/>
+        </p:spPr>
+        <p:txBody>
+          <a:bodyPr wrap="square" lIns="0" tIns="0" rIns="0" bIns="0" rtlCol="0" anchor="ctr"/>
+          <a:lstStyle/>
+          <a:p>
+            <a:pPr algn="r" indent="0" marL="0">
+              <a:buNone/>
+            </a:pPr>
+            <a:r>
+              <a:rPr lang="en-US" sz="2400" b="1" dirty="0">
+                <a:solidFill>
+                  <a:srgbClr val="E7B3C4"/>
+                </a:solidFill>
+                <a:latin typeface="Arial" pitchFamily="34" charset="0"/>
+                <a:ea typeface="Arial" pitchFamily="34" charset="-122"/>
+                <a:cs typeface="Arial" pitchFamily="34" charset="-120"/>
+              </a:rPr>
+              <a:t>1</a:t>
+            </a:r>
+            <a:endParaRPr lang="en-US" sz="2400" dirty="0"/>
+          </a:p>
+        </p:txBody>
+      </p:sp>
+      <p:sp>
+        <p:nvSpPr>
+          <p:cNvPr id="9" name="Text 5"/>
+          <p:cNvSpPr txBox="1"/>
+          <p:nvPr/>
+        </p:nvSpPr>
+        <p:spPr>
+          <a:xfrm>
+            <a:off x="640080" y="2148840"/>
+            <a:ext cx="1600200" cy="320040"/>
+          </a:xfrm>
+          <a:prstGeom prst="rect">
+            <a:avLst/>
+          </a:prstGeom>
+          <a:noFill/>
+          <a:ln/>
+        </p:spPr>
+        <p:txBody>
+          <a:bodyPr wrap="square" lIns="0" tIns="0" rIns="0" bIns="0" rtlCol="0" anchor="ctr"/>
+          <a:lstStyle/>
+          <a:p>
+            <a:pPr indent="0" marL="0">
+              <a:buNone/>
+            </a:pPr>
+            <a:r>
+              <a:rPr lang="en-US" sz="1400" b="1" dirty="0">
+                <a:solidFill>
+                  <a:srgbClr val="2B1A22"/>
+                </a:solidFill>
+                <a:latin typeface="Arial" pitchFamily="34" charset="0"/>
+                <a:ea typeface="Arial" pitchFamily="34" charset="-122"/>
+                <a:cs typeface="Arial" pitchFamily="34" charset="-120"/>
+              </a:rPr>
+              <a:t>Counsellor</a:t>
+            </a:r>
+            <a:endParaRPr lang="en-US" sz="1400" dirty="0"/>
+          </a:p>
+        </p:txBody>
+      </p:sp>
+      <p:sp>
+        <p:nvSpPr>
+          <p:cNvPr id="10" name="Text 6"/>
+          <p:cNvSpPr txBox="1"/>
+          <p:nvPr/>
+        </p:nvSpPr>
+        <p:spPr>
+          <a:xfrm>
+            <a:off x="640080" y="2514600"/>
+            <a:ext cx="1554480" cy="1417320"/>
+          </a:xfrm>
+          <a:prstGeom prst="rect">
+            <a:avLst/>
+          </a:prstGeom>
+          <a:noFill/>
+          <a:ln/>
+        </p:spPr>
+        <p:txBody>
+          <a:bodyPr wrap="square" lIns="0" tIns="0" rIns="0" bIns="0" rtlCol="0" anchor="t"/>
+          <a:lstStyle/>
+          <a:p>
+            <a:pPr indent="0" marL="0">
+              <a:buNone/>
+            </a:pPr>
+            <a:r>
+              <a:rPr lang="en-US" sz="1150" dirty="0">
+                <a:solidFill>
+                  <a:srgbClr val="6B5A62"/>
+                </a:solidFill>
+                <a:latin typeface="Calibri" pitchFamily="34" charset="0"/>
+                <a:ea typeface="Calibri" pitchFamily="34" charset="-122"/>
+                <a:cs typeface="Calibri" pitchFamily="34" charset="-120"/>
+              </a:rPr>
+              <a:t>Collects student details and fills the Refund Request Form, incl. incentives claimed</a:t>
+            </a:r>
+            <a:endParaRPr lang="en-US" sz="1150" dirty="0"/>
+          </a:p>
+        </p:txBody>
+      </p:sp>
+      <p:pic>
+        <p:nvPicPr>
+          <p:cNvPr id="11" name="Image 2" descr="preencoded.png">    </p:cNvPr>
+          <p:cNvPicPr>
+            <a:picLocks noChangeAspect="1"/>
+          </p:cNvPicPr>
+          <p:nvPr/>
+        </p:nvPicPr>
+        <p:blipFill>
+          <a:blip r:embed="rId3"/>
+          <a:stretch>
+            <a:fillRect/>
+          </a:stretch>
+        </p:blipFill>
+        <p:spPr>
+          <a:xfrm>
+            <a:off x="2350008" y="2542032"/>
+            <a:ext cx="182880" cy="182880"/>
+          </a:xfrm>
+          <a:prstGeom prst="rect">
+            <a:avLst/>
+          </a:prstGeom>
+        </p:spPr>
+      </p:pic>
+      <p:sp>
+        <p:nvSpPr>
+          <p:cNvPr id="12" name="Shape 7"/>
+          <p:cNvSpPr/>
+          <p:nvPr/>
+        </p:nvSpPr>
+        <p:spPr>
+          <a:xfrm>
+            <a:off x="2560320" y="1280160"/>
+            <a:ext cx="1874520" cy="2743200"/>
+          </a:xfrm>
+          <a:prstGeom prst="roundRect">
+            <a:avLst>
+              <a:gd name="adj" fmla="val 5854"/>
+            </a:avLst>
+          </a:prstGeom>
+          <a:solidFill>
+            <a:srgbClr val="FFFFFF"/>
+          </a:solidFill>
+          <a:ln w="9525">
+            <a:solidFill>
+              <a:srgbClr val="EBD3DC"/>
+            </a:solidFill>
+            <a:prstDash val="solid"/>
+          </a:ln>
+          <a:effectLst>
+            <a:outerShdw sx="100000" sy="100000" kx="0" ky="0" algn="bl" rotWithShape="0" blurRad="76200" dist="25400" dir="5400000">
+              <a:srgbClr val="000000">
+                <a:alpha val="12000"/>
+              </a:srgbClr>
+            </a:outerShdw>
+          </a:effectLst>
+        </p:spPr>
+      </p:sp>
+      <p:sp>
+        <p:nvSpPr>
+          <p:cNvPr id="13" name="Shape 8"/>
+          <p:cNvSpPr/>
+          <p:nvPr/>
+        </p:nvSpPr>
+        <p:spPr>
+          <a:xfrm>
+            <a:off x="2743200" y="1463040"/>
+            <a:ext cx="548640" cy="548640"/>
+          </a:xfrm>
+          <a:prstGeom prst="ellipse">
+            <a:avLst/>
+          </a:prstGeom>
+          <a:solidFill>
+            <a:srgbClr val="C01F53"/>
+          </a:solidFill>
+          <a:ln w="12700">
+            <a:solidFill>
+              <a:srgbClr val="C01F53"/>
+            </a:solidFill>
+            <a:prstDash val="solid"/>
+          </a:ln>
+        </p:spPr>
+      </p:sp>
+      <p:pic>
+        <p:nvPicPr>
+          <p:cNvPr id="14" name="Image 3" descr="preencoded.png">    </p:cNvPr>
+          <p:cNvPicPr>
+            <a:picLocks noChangeAspect="1"/>
+          </p:cNvPicPr>
+          <p:nvPr/>
+        </p:nvPicPr>
+        <p:blipFill>
+          <a:blip r:embed="rId4"/>
+          <a:stretch>
+            <a:fillRect/>
+          </a:stretch>
+        </p:blipFill>
+        <p:spPr>
+          <a:xfrm>
+            <a:off x="2880360" y="1600200"/>
+            <a:ext cx="274320" cy="274320"/>
+          </a:xfrm>
+          <a:prstGeom prst="rect">
+            <a:avLst/>
+          </a:prstGeom>
+        </p:spPr>
+      </p:pic>
+      <p:sp>
+        <p:nvSpPr>
+          <p:cNvPr id="15" name="Text 9"/>
+          <p:cNvSpPr txBox="1"/>
+          <p:nvPr/>
+        </p:nvSpPr>
+        <p:spPr>
+          <a:xfrm>
+            <a:off x="3749040" y="1463040"/>
+            <a:ext cx="548640" cy="457200"/>
+          </a:xfrm>
+          <a:prstGeom prst="rect">
+            <a:avLst/>
+          </a:prstGeom>
+          <a:noFill/>
+          <a:ln/>
+        </p:spPr>
+        <p:txBody>
+          <a:bodyPr wrap="square" lIns="0" tIns="0" rIns="0" bIns="0" rtlCol="0" anchor="ctr"/>
+          <a:lstStyle/>
+          <a:p>
+            <a:pPr algn="r" indent="0" marL="0">
+              <a:buNone/>
+            </a:pPr>
+            <a:r>
+              <a:rPr lang="en-US" sz="2400" b="1" dirty="0">
+                <a:solidFill>
+                  <a:srgbClr val="E7B3C4"/>
+                </a:solidFill>
+                <a:latin typeface="Arial" pitchFamily="34" charset="0"/>
+                <a:ea typeface="Arial" pitchFamily="34" charset="-122"/>
+                <a:cs typeface="Arial" pitchFamily="34" charset="-120"/>
+              </a:rPr>
+              <a:t>2</a:t>
+            </a:r>
+            <a:endParaRPr lang="en-US" sz="2400" dirty="0"/>
+          </a:p>
+        </p:txBody>
+      </p:sp>
+      <p:sp>
+        <p:nvSpPr>
+          <p:cNvPr id="16" name="Text 10"/>
+          <p:cNvSpPr txBox="1"/>
+          <p:nvPr/>
+        </p:nvSpPr>
+        <p:spPr>
+          <a:xfrm>
+            <a:off x="2743200" y="2148840"/>
+            <a:ext cx="1600200" cy="320040"/>
+          </a:xfrm>
+          <a:prstGeom prst="rect">
+            <a:avLst/>
+          </a:prstGeom>
+          <a:noFill/>
+          <a:ln/>
+        </p:spPr>
+        <p:txBody>
+          <a:bodyPr wrap="square" lIns="0" tIns="0" rIns="0" bIns="0" rtlCol="0" anchor="ctr"/>
+          <a:lstStyle/>
+          <a:p>
+            <a:pPr indent="0" marL="0">
+              <a:buNone/>
+            </a:pPr>
+            <a:r>
+              <a:rPr lang="en-US" sz="1400" b="1" dirty="0">
+                <a:solidFill>
+                  <a:srgbClr val="2B1A22"/>
+                </a:solidFill>
+                <a:latin typeface="Arial" pitchFamily="34" charset="0"/>
+                <a:ea typeface="Arial" pitchFamily="34" charset="-122"/>
+                <a:cs typeface="Arial" pitchFamily="34" charset="-120"/>
+              </a:rPr>
+              <a:t>Formal Email</a:t>
+            </a:r>
+            <a:endParaRPr lang="en-US" sz="1400" dirty="0"/>
+          </a:p>
+        </p:txBody>
+      </p:sp>
+      <p:sp>
+        <p:nvSpPr>
+          <p:cNvPr id="17" name="Text 11"/>
+          <p:cNvSpPr txBox="1"/>
+          <p:nvPr/>
+        </p:nvSpPr>
+        <p:spPr>
+          <a:xfrm>
+            <a:off x="2743200" y="2514600"/>
+            <a:ext cx="1554480" cy="1417320"/>
+          </a:xfrm>
+          <a:prstGeom prst="rect">
+            <a:avLst/>
+          </a:prstGeom>
+          <a:noFill/>
+          <a:ln/>
+        </p:spPr>
+        <p:txBody>
+          <a:bodyPr wrap="square" lIns="0" tIns="0" rIns="0" bIns="0" rtlCol="0" anchor="t"/>
+          <a:lstStyle/>
+          <a:p>
+            <a:pPr indent="0" marL="0">
+              <a:buNone/>
+            </a:pPr>
+            <a:r>
+              <a:rPr lang="en-US" sz="1150" dirty="0">
+                <a:solidFill>
+                  <a:srgbClr val="6B5A62"/>
+                </a:solidFill>
+                <a:latin typeface="Calibri" pitchFamily="34" charset="0"/>
+                <a:ea typeface="Calibri" pitchFamily="34" charset="-122"/>
+                <a:cs typeface="Calibri" pitchFamily="34" charset="-120"/>
+              </a:rPr>
+              <a:t>Counsellor emails the completed form and details to the Branch Head / Regional Manager</a:t>
+            </a:r>
+            <a:endParaRPr lang="en-US" sz="1150" dirty="0"/>
+          </a:p>
+        </p:txBody>
+      </p:sp>
+      <p:pic>
+        <p:nvPicPr>
+          <p:cNvPr id="18" name="Image 4" descr="preencoded.png">    </p:cNvPr>
+          <p:cNvPicPr>
+            <a:picLocks noChangeAspect="1"/>
+          </p:cNvPicPr>
+          <p:nvPr/>
+        </p:nvPicPr>
+        <p:blipFill>
+          <a:blip r:embed="rId5"/>
+          <a:stretch>
+            <a:fillRect/>
+          </a:stretch>
+        </p:blipFill>
+        <p:spPr>
+          <a:xfrm>
+            <a:off x="4453128" y="2542032"/>
+            <a:ext cx="182880" cy="182880"/>
+          </a:xfrm>
+          <a:prstGeom prst="rect">
+            <a:avLst/>
+          </a:prstGeom>
+        </p:spPr>
+      </p:pic>
+      <p:sp>
+        <p:nvSpPr>
+          <p:cNvPr id="19" name="Shape 12"/>
+          <p:cNvSpPr/>
+          <p:nvPr/>
+        </p:nvSpPr>
+        <p:spPr>
+          <a:xfrm>
+            <a:off x="4663440" y="1280160"/>
+            <a:ext cx="1874520" cy="2743200"/>
+          </a:xfrm>
+          <a:prstGeom prst="roundRect">
+            <a:avLst>
+              <a:gd name="adj" fmla="val 5854"/>
+            </a:avLst>
+          </a:prstGeom>
+          <a:solidFill>
+            <a:srgbClr val="FFFFFF"/>
+          </a:solidFill>
+          <a:ln w="9525">
+            <a:solidFill>
+              <a:srgbClr val="EBD3DC"/>
+            </a:solidFill>
+            <a:prstDash val="solid"/>
+          </a:ln>
+          <a:effectLst>
+            <a:outerShdw sx="100000" sy="100000" kx="0" ky="0" algn="bl" rotWithShape="0" blurRad="76200" dist="25400" dir="5400000">
+              <a:srgbClr val="000000">
+                <a:alpha val="12000"/>
+              </a:srgbClr>
+            </a:outerShdw>
+          </a:effectLst>
+        </p:spPr>
+      </p:sp>
+      <p:sp>
+        <p:nvSpPr>
+          <p:cNvPr id="20" name="Shape 13"/>
+          <p:cNvSpPr/>
+          <p:nvPr/>
+        </p:nvSpPr>
+        <p:spPr>
+          <a:xfrm>
+            <a:off x="4846320" y="1463040"/>
+            <a:ext cx="548640" cy="548640"/>
+          </a:xfrm>
+          <a:prstGeom prst="ellipse">
+            <a:avLst/>
+          </a:prstGeom>
+          <a:solidFill>
+            <a:srgbClr val="C01F53"/>
+          </a:solidFill>
+          <a:ln w="12700">
+            <a:solidFill>
+              <a:srgbClr val="C01F53"/>
+            </a:solidFill>
+            <a:prstDash val="solid"/>
+          </a:ln>
+        </p:spPr>
+      </p:sp>
+      <p:pic>
+        <p:nvPicPr>
+          <p:cNvPr id="21" name="Image 5" descr="preencoded.png">    </p:cNvPr>
+          <p:cNvPicPr>
+            <a:picLocks noChangeAspect="1"/>
+          </p:cNvPicPr>
+          <p:nvPr/>
+        </p:nvPicPr>
+        <p:blipFill>
+          <a:blip r:embed="rId6"/>
+          <a:stretch>
+            <a:fillRect/>
+          </a:stretch>
+        </p:blipFill>
+        <p:spPr>
+          <a:xfrm>
+            <a:off x="4983480" y="1600200"/>
+            <a:ext cx="274320" cy="274320"/>
+          </a:xfrm>
+          <a:prstGeom prst="rect">
+            <a:avLst/>
+          </a:prstGeom>
+        </p:spPr>
+      </p:pic>
+      <p:sp>
+        <p:nvSpPr>
+          <p:cNvPr id="22" name="Text 14"/>
+          <p:cNvSpPr txBox="1"/>
+          <p:nvPr/>
+        </p:nvSpPr>
+        <p:spPr>
+          <a:xfrm>
+            <a:off x="5852160" y="1463040"/>
+            <a:ext cx="548640" cy="457200"/>
+          </a:xfrm>
+          <a:prstGeom prst="rect">
+            <a:avLst/>
+          </a:prstGeom>
+          <a:noFill/>
+          <a:ln/>
+        </p:spPr>
+        <p:txBody>
+          <a:bodyPr wrap="square" lIns="0" tIns="0" rIns="0" bIns="0" rtlCol="0" anchor="ctr"/>
+          <a:lstStyle/>
+          <a:p>
+            <a:pPr algn="r" indent="0" marL="0">
+              <a:buNone/>
+            </a:pPr>
+            <a:r>
+              <a:rPr lang="en-US" sz="2400" b="1" dirty="0">
+                <a:solidFill>
+                  <a:srgbClr val="E7B3C4"/>
+                </a:solidFill>
+                <a:latin typeface="Arial" pitchFamily="34" charset="0"/>
+                <a:ea typeface="Arial" pitchFamily="34" charset="-122"/>
+                <a:cs typeface="Arial" pitchFamily="34" charset="-120"/>
+              </a:rPr>
+              <a:t>3</a:t>
+            </a:r>
+            <a:endParaRPr lang="en-US" sz="2400" dirty="0"/>
+          </a:p>
+        </p:txBody>
+      </p:sp>
+      <p:sp>
+        <p:nvSpPr>
+          <p:cNvPr id="23" name="Text 15"/>
+          <p:cNvSpPr txBox="1"/>
+          <p:nvPr/>
+        </p:nvSpPr>
+        <p:spPr>
+          <a:xfrm>
+            <a:off x="4846320" y="2148840"/>
+            <a:ext cx="1600200" cy="320040"/>
+          </a:xfrm>
+          <a:prstGeom prst="rect">
+            <a:avLst/>
+          </a:prstGeom>
+          <a:noFill/>
+          <a:ln/>
+        </p:spPr>
+        <p:txBody>
+          <a:bodyPr wrap="square" lIns="0" tIns="0" rIns="0" bIns="0" rtlCol="0" anchor="ctr"/>
+          <a:lstStyle/>
+          <a:p>
+            <a:pPr indent="0" marL="0">
+              <a:buNone/>
+            </a:pPr>
+            <a:r>
+              <a:rPr lang="en-US" sz="1400" b="1" dirty="0">
+                <a:solidFill>
+                  <a:srgbClr val="2B1A22"/>
+                </a:solidFill>
+                <a:latin typeface="Arial" pitchFamily="34" charset="0"/>
+                <a:ea typeface="Arial" pitchFamily="34" charset="-122"/>
+                <a:cs typeface="Arial" pitchFamily="34" charset="-120"/>
+              </a:rPr>
+              <a:t>Branch Head</a:t>
+            </a:r>
+            <a:endParaRPr lang="en-US" sz="1400" dirty="0"/>
+          </a:p>
+        </p:txBody>
+      </p:sp>
+      <p:sp>
+        <p:nvSpPr>
+          <p:cNvPr id="24" name="Text 16"/>
+          <p:cNvSpPr txBox="1"/>
+          <p:nvPr/>
+        </p:nvSpPr>
+        <p:spPr>
+          <a:xfrm>
+            <a:off x="4846320" y="2514600"/>
+            <a:ext cx="1554480" cy="1417320"/>
+          </a:xfrm>
+          <a:prstGeom prst="rect">
+            <a:avLst/>
+          </a:prstGeom>
+          <a:noFill/>
+          <a:ln/>
+        </p:spPr>
+        <p:txBody>
+          <a:bodyPr wrap="square" lIns="0" tIns="0" rIns="0" bIns="0" rtlCol="0" anchor="t"/>
+          <a:lstStyle/>
+          <a:p>
+            <a:pPr indent="0" marL="0">
+              <a:buNone/>
+            </a:pPr>
+            <a:r>
+              <a:rPr lang="en-US" sz="1150" dirty="0">
+                <a:solidFill>
+                  <a:srgbClr val="6B5A62"/>
+                </a:solidFill>
+                <a:latin typeface="Calibri" pitchFamily="34" charset="0"/>
+                <a:ea typeface="Calibri" pitchFamily="34" charset="-122"/>
+                <a:cs typeface="Calibri" pitchFamily="34" charset="-120"/>
+              </a:rPr>
+              <a:t>Reviews and verifies, then forwards to the International Relations Manager — ATL in CC</a:t>
+            </a:r>
+            <a:endParaRPr lang="en-US" sz="1150" dirty="0"/>
+          </a:p>
+        </p:txBody>
+      </p:sp>
+      <p:pic>
+        <p:nvPicPr>
+          <p:cNvPr id="25" name="Image 6" descr="preencoded.png">    </p:cNvPr>
+          <p:cNvPicPr>
+            <a:picLocks noChangeAspect="1"/>
+          </p:cNvPicPr>
+          <p:nvPr/>
+        </p:nvPicPr>
+        <p:blipFill>
+          <a:blip r:embed="rId7"/>
+          <a:stretch>
+            <a:fillRect/>
+          </a:stretch>
+        </p:blipFill>
+        <p:spPr>
+          <a:xfrm>
+            <a:off x="6556248" y="2542032"/>
+            <a:ext cx="182880" cy="182880"/>
+          </a:xfrm>
+          <a:prstGeom prst="rect">
+            <a:avLst/>
+          </a:prstGeom>
+        </p:spPr>
+      </p:pic>
+      <p:sp>
+        <p:nvSpPr>
+          <p:cNvPr id="26" name="Shape 17"/>
+          <p:cNvSpPr/>
+          <p:nvPr/>
+        </p:nvSpPr>
+        <p:spPr>
+          <a:xfrm>
+            <a:off x="6766560" y="1280160"/>
+            <a:ext cx="1874520" cy="2743200"/>
+          </a:xfrm>
+          <a:prstGeom prst="roundRect">
+            <a:avLst>
+              <a:gd name="adj" fmla="val 5854"/>
+            </a:avLst>
+          </a:prstGeom>
+          <a:solidFill>
+            <a:srgbClr val="FBEFF3"/>
+          </a:solidFill>
+          <a:ln w="9525">
+            <a:solidFill>
+              <a:srgbClr val="EBD3DC"/>
+            </a:solidFill>
+            <a:prstDash val="solid"/>
+          </a:ln>
+          <a:effectLst>
+            <a:outerShdw sx="100000" sy="100000" kx="0" ky="0" algn="bl" rotWithShape="0" blurRad="76200" dist="25400" dir="5400000">
+              <a:srgbClr val="000000">
+                <a:alpha val="12000"/>
+              </a:srgbClr>
+            </a:outerShdw>
+          </a:effectLst>
+        </p:spPr>
+      </p:sp>
+      <p:sp>
+        <p:nvSpPr>
+          <p:cNvPr id="27" name="Shape 18"/>
+          <p:cNvSpPr/>
+          <p:nvPr/>
+        </p:nvSpPr>
+        <p:spPr>
+          <a:xfrm>
+            <a:off x="6949440" y="1463040"/>
+            <a:ext cx="548640" cy="548640"/>
+          </a:xfrm>
+          <a:prstGeom prst="ellipse">
+            <a:avLst/>
+          </a:prstGeom>
+          <a:solidFill>
+            <a:srgbClr val="C01F53"/>
+          </a:solidFill>
+          <a:ln w="12700">
+            <a:solidFill>
+              <a:srgbClr val="C01F53"/>
+            </a:solidFill>
+            <a:prstDash val="solid"/>
+          </a:ln>
+        </p:spPr>
+      </p:sp>
+      <p:pic>
+        <p:nvPicPr>
+          <p:cNvPr id="28" name="Image 7" descr="preencoded.png">    </p:cNvPr>
+          <p:cNvPicPr>
+            <a:picLocks noChangeAspect="1"/>
+          </p:cNvPicPr>
+          <p:nvPr/>
+        </p:nvPicPr>
+        <p:blipFill>
+          <a:blip r:embed="rId8"/>
+          <a:stretch>
+            <a:fillRect/>
+          </a:stretch>
+        </p:blipFill>
+        <p:spPr>
+          <a:xfrm>
+            <a:off x="7086600" y="1600200"/>
+            <a:ext cx="274320" cy="274320"/>
+          </a:xfrm>
+          <a:prstGeom prst="rect">
+            <a:avLst/>
+          </a:prstGeom>
+        </p:spPr>
+      </p:pic>
+      <p:sp>
+        <p:nvSpPr>
+          <p:cNvPr id="29" name="Text 19"/>
+          <p:cNvSpPr txBox="1"/>
+          <p:nvPr/>
+        </p:nvSpPr>
+        <p:spPr>
+          <a:xfrm>
+            <a:off x="7955280" y="1463040"/>
+            <a:ext cx="548640" cy="457200"/>
+          </a:xfrm>
+          <a:prstGeom prst="rect">
+            <a:avLst/>
+          </a:prstGeom>
+          <a:noFill/>
+          <a:ln/>
+        </p:spPr>
+        <p:txBody>
+          <a:bodyPr wrap="square" lIns="0" tIns="0" rIns="0" bIns="0" rtlCol="0" anchor="ctr"/>
+          <a:lstStyle/>
+          <a:p>
+            <a:pPr algn="r" indent="0" marL="0">
+              <a:buNone/>
+            </a:pPr>
+            <a:r>
+              <a:rPr lang="en-US" sz="2400" b="1" dirty="0">
+                <a:solidFill>
+                  <a:srgbClr val="E7B3C4"/>
+                </a:solidFill>
+                <a:latin typeface="Arial" pitchFamily="34" charset="0"/>
+                <a:ea typeface="Arial" pitchFamily="34" charset="-122"/>
+                <a:cs typeface="Arial" pitchFamily="34" charset="-120"/>
+              </a:rPr>
+              <a:t>4</a:t>
+            </a:r>
+            <a:endParaRPr lang="en-US" sz="2400" dirty="0"/>
+          </a:p>
+        </p:txBody>
+      </p:sp>
+      <p:sp>
+        <p:nvSpPr>
+          <p:cNvPr id="30" name="Text 20"/>
+          <p:cNvSpPr txBox="1"/>
+          <p:nvPr/>
+        </p:nvSpPr>
+        <p:spPr>
+          <a:xfrm>
+            <a:off x="6949440" y="2148840"/>
+            <a:ext cx="1600200" cy="320040"/>
+          </a:xfrm>
+          <a:prstGeom prst="rect">
+            <a:avLst/>
+          </a:prstGeom>
+          <a:noFill/>
+          <a:ln/>
+        </p:spPr>
+        <p:txBody>
+          <a:bodyPr wrap="square" lIns="0" tIns="0" rIns="0" bIns="0" rtlCol="0" anchor="ctr"/>
+          <a:lstStyle/>
+          <a:p>
+            <a:pPr indent="0" marL="0">
+              <a:buNone/>
+            </a:pPr>
+            <a:r>
+              <a:rPr lang="en-US" sz="1400" b="1" dirty="0">
+                <a:solidFill>
+                  <a:srgbClr val="2B1A22"/>
+                </a:solidFill>
+                <a:latin typeface="Arial" pitchFamily="34" charset="0"/>
+                <a:ea typeface="Arial" pitchFamily="34" charset="-122"/>
+                <a:cs typeface="Arial" pitchFamily="34" charset="-120"/>
+              </a:rPr>
+              <a:t>IRM Verification</a:t>
+            </a:r>
+            <a:endParaRPr lang="en-US" sz="1400" dirty="0"/>
+          </a:p>
+        </p:txBody>
+      </p:sp>
+      <p:sp>
+        <p:nvSpPr>
+          <p:cNvPr id="31" name="Text 21"/>
+          <p:cNvSpPr txBox="1"/>
+          <p:nvPr/>
+        </p:nvSpPr>
+        <p:spPr>
+          <a:xfrm>
+            <a:off x="6949440" y="2514600"/>
+            <a:ext cx="1554480" cy="1417320"/>
+          </a:xfrm>
+          <a:prstGeom prst="rect">
+            <a:avLst/>
+          </a:prstGeom>
+          <a:noFill/>
+          <a:ln/>
+        </p:spPr>
+        <p:txBody>
+          <a:bodyPr wrap="square" lIns="0" tIns="0" rIns="0" bIns="0" rtlCol="0" anchor="t"/>
+          <a:lstStyle/>
+          <a:p>
+            <a:pPr indent="0" marL="0">
+              <a:buNone/>
+            </a:pPr>
+            <a:r>
+              <a:rPr lang="en-US" sz="1150" dirty="0">
+                <a:solidFill>
+                  <a:srgbClr val="6B5A62"/>
+                </a:solidFill>
+                <a:latin typeface="Calibri" pitchFamily="34" charset="0"/>
+                <a:ea typeface="Calibri" pitchFamily="34" charset="-122"/>
+                <a:cs typeface="Calibri" pitchFamily="34" charset="-120"/>
+              </a:rPr>
+              <a:t>International Relations Manager verifies status, payments, services and documents</a:t>
+            </a:r>
+            <a:endParaRPr lang="en-US" sz="1150" dirty="0"/>
+          </a:p>
+        </p:txBody>
+      </p:sp>
+      <p:sp>
+        <p:nvSpPr>
+          <p:cNvPr id="32" name="Shape 22"/>
+          <p:cNvSpPr/>
+          <p:nvPr/>
+        </p:nvSpPr>
+        <p:spPr>
+          <a:xfrm>
+            <a:off x="457200" y="4206240"/>
+            <a:ext cx="8183880" cy="502920"/>
+          </a:xfrm>
+          <a:prstGeom prst="roundRect">
+            <a:avLst>
+              <a:gd name="adj" fmla="val 21818"/>
+            </a:avLst>
+          </a:prstGeom>
+          <a:solidFill>
+            <a:srgbClr val="FFFBD6"/>
+          </a:solidFill>
+          <a:ln w="9525">
+            <a:solidFill>
+              <a:srgbClr val="EBD3DC"/>
+            </a:solidFill>
+            <a:prstDash val="solid"/>
+          </a:ln>
+          <a:effectLst>
+            <a:outerShdw sx="100000" sy="100000" kx="0" ky="0" algn="bl" rotWithShape="0" blurRad="76200" dist="25400" dir="5400000">
+              <a:srgbClr val="000000">
+                <a:alpha val="12000"/>
+              </a:srgbClr>
+            </a:outerShdw>
+          </a:effectLst>
+        </p:spPr>
+      </p:sp>
+      <p:sp>
+        <p:nvSpPr>
+          <p:cNvPr id="33" name="Text 23"/>
+          <p:cNvSpPr txBox="1"/>
+          <p:nvPr/>
+        </p:nvSpPr>
+        <p:spPr>
+          <a:xfrm>
+            <a:off x="640080" y="4206240"/>
+            <a:ext cx="7863840" cy="502920"/>
+          </a:xfrm>
+          <a:prstGeom prst="rect">
+            <a:avLst/>
+          </a:prstGeom>
+          <a:noFill/>
+          <a:ln/>
+        </p:spPr>
+        <p:txBody>
+          <a:bodyPr wrap="square" lIns="0" tIns="0" rIns="0" bIns="0" rtlCol="0" anchor="ctr"/>
+          <a:lstStyle/>
+          <a:p>
+            <a:pPr indent="0" marL="0">
+              <a:buNone/>
+            </a:pPr>
+            <a:r>
+              <a:rPr lang="en-US" sz="1300" b="1" dirty="0">
+                <a:solidFill>
+                  <a:srgbClr val="C01F53"/>
+                </a:solidFill>
+                <a:latin typeface="Calibri" pitchFamily="34" charset="0"/>
+                <a:ea typeface="Calibri" pitchFamily="34" charset="-122"/>
+                <a:cs typeface="Calibri" pitchFamily="34" charset="-120"/>
+              </a:rPr>
+              <a:t>Rule: </a:t>
+            </a:r>
+            <a:pPr indent="0" marL="0">
+              <a:buNone/>
+            </a:pPr>
+            <a:r>
+              <a:rPr lang="en-US" sz="1300" dirty="0">
+                <a:solidFill>
+                  <a:srgbClr val="2B1A22"/>
+                </a:solidFill>
+                <a:latin typeface="Calibri" pitchFamily="34" charset="0"/>
+                <a:ea typeface="Calibri" pitchFamily="34" charset="-122"/>
+                <a:cs typeface="Calibri" pitchFamily="34" charset="-120"/>
+              </a:rPr>
+              <a:t>Any discrepancy or missing information must be clarified before it proceeds.</a:t>
+            </a:r>
+            <a:endParaRPr lang="en-US" sz="1300" dirty="0"/>
+          </a:p>
+        </p:txBody>
+      </p:sp>
+    </p:spTree>
+  </p:cSld>
+  <p:clrMapOvr>
+    <a:masterClrMapping/>
+  </p:clrMapOvr>
+</p:sld>
+</file>
+
+<file path=ppt/slides/slide15.xml><?xml version="1.0" encoding="utf-8"?>
+<p:sld xmlns:a="http://schemas.openxmlformats.org/drawingml/2006/main" xmlns:r="http://schemas.openxmlformats.org/officeDocument/2006/relationships" xmlns:p="http://schemas.openxmlformats.org/presentationml/2006/main">
+  <p:cSld name="Slide 15">
+    <p:bg>
+      <p:bgPr>
+        <a:solidFill>
+          <a:srgbClr val="FFFFFF"/>
+        </a:solidFill>
+      </p:bgPr>
+    </p:bg>
+    <p:spTree>
+      <p:nvGrpSpPr>
+        <p:cNvPr id="1" name=""/>
+        <p:cNvGrpSpPr/>
+        <p:nvPr/>
+      </p:nvGrpSpPr>
+      <p:grpSpPr>
+        <a:xfrm>
+          <a:off x="0" y="0"/>
+          <a:ext cx="0" cy="0"/>
+          <a:chOff x="0" y="0"/>
+          <a:chExt cx="0" cy="0"/>
+        </a:xfrm>
+      </p:grpSpPr>
+      <p:sp>
+        <p:nvSpPr>
+          <p:cNvPr id="2" name="Text 0"/>
+          <p:cNvSpPr txBox="1"/>
+          <p:nvPr/>
+        </p:nvSpPr>
+        <p:spPr>
+          <a:xfrm>
+            <a:off x="457200" y="274320"/>
+            <a:ext cx="6492240" cy="457200"/>
+          </a:xfrm>
+          <a:prstGeom prst="rect">
+            <a:avLst/>
+          </a:prstGeom>
+          <a:noFill/>
+          <a:ln/>
+        </p:spPr>
+        <p:txBody>
+          <a:bodyPr wrap="square" lIns="0" tIns="0" rIns="0" bIns="0" rtlCol="0" anchor="ctr"/>
+          <a:lstStyle/>
+          <a:p>
+            <a:pPr indent="0" marL="0">
+              <a:buNone/>
+            </a:pPr>
+            <a:r>
+              <a:rPr lang="en-US" sz="2600" b="1" dirty="0">
+                <a:solidFill>
+                  <a:srgbClr val="2B1A22"/>
+                </a:solidFill>
+                <a:latin typeface="Arial" pitchFamily="34" charset="0"/>
+                <a:ea typeface="Arial" pitchFamily="34" charset="-122"/>
+                <a:cs typeface="Arial" pitchFamily="34" charset="-120"/>
+              </a:rPr>
+              <a:t>Refund: What Must Be Checked</a:t>
+            </a:r>
+            <a:endParaRPr lang="en-US" sz="2600" dirty="0"/>
+          </a:p>
+        </p:txBody>
+      </p:sp>
+      <p:sp>
+        <p:nvSpPr>
+          <p:cNvPr id="3" name="Text 1"/>
+          <p:cNvSpPr txBox="1"/>
+          <p:nvPr/>
+        </p:nvSpPr>
+        <p:spPr>
+          <a:xfrm>
+            <a:off x="457200" y="713232"/>
+            <a:ext cx="6675120" cy="274320"/>
+          </a:xfrm>
+          <a:prstGeom prst="rect">
+            <a:avLst/>
+          </a:prstGeom>
+          <a:noFill/>
+          <a:ln/>
+        </p:spPr>
+        <p:txBody>
+          <a:bodyPr wrap="square" lIns="0" tIns="0" rIns="0" bIns="0" rtlCol="0" anchor="ctr"/>
+          <a:lstStyle/>
+          <a:p>
+            <a:pPr indent="0" marL="0">
+              <a:buNone/>
+            </a:pPr>
+            <a:r>
+              <a:rPr lang="en-US" sz="1300" i="1" dirty="0">
+                <a:solidFill>
+                  <a:srgbClr val="C01F53"/>
+                </a:solidFill>
+                <a:latin typeface="Calibri" pitchFamily="34" charset="0"/>
+                <a:ea typeface="Calibri" pitchFamily="34" charset="-122"/>
+                <a:cs typeface="Calibri" pitchFamily="34" charset="-120"/>
+              </a:rPr>
+              <a:t>Counsellor prepares it — IRM verifies it</a:t>
+            </a:r>
+            <a:endParaRPr lang="en-US" sz="1300" dirty="0"/>
+          </a:p>
+        </p:txBody>
+      </p:sp>
+      <p:pic>
+        <p:nvPicPr>
+          <p:cNvPr id="4" name="Image 0" descr="preencoded.png">    </p:cNvPr>
+          <p:cNvPicPr>
+            <a:picLocks noChangeAspect="1"/>
+          </p:cNvPicPr>
+          <p:nvPr/>
+        </p:nvPicPr>
+        <p:blipFill>
+          <a:blip r:embed="rId1"/>
+          <a:stretch>
+            <a:fillRect/>
+          </a:stretch>
+        </p:blipFill>
+        <p:spPr>
+          <a:xfrm>
+            <a:off x="8183880" y="274320"/>
+            <a:ext cx="548640" cy="548640"/>
+          </a:xfrm>
+          <a:prstGeom prst="rect">
+            <a:avLst/>
+          </a:prstGeom>
+        </p:spPr>
+      </p:pic>
+      <p:sp>
+        <p:nvSpPr>
+          <p:cNvPr id="5" name="Shape 2"/>
+          <p:cNvSpPr/>
+          <p:nvPr/>
+        </p:nvSpPr>
+        <p:spPr>
+          <a:xfrm>
+            <a:off x="457200" y="1234440"/>
+            <a:ext cx="3977640" cy="3429000"/>
+          </a:xfrm>
+          <a:prstGeom prst="roundRect">
+            <a:avLst>
+              <a:gd name="adj" fmla="val 3200"/>
+            </a:avLst>
+          </a:prstGeom>
+          <a:solidFill>
+            <a:srgbClr val="FFFFFF"/>
+          </a:solidFill>
+          <a:ln w="9525">
+            <a:solidFill>
+              <a:srgbClr val="EBD3DC"/>
+            </a:solidFill>
+            <a:prstDash val="solid"/>
+          </a:ln>
+          <a:effectLst>
+            <a:outerShdw sx="100000" sy="100000" kx="0" ky="0" algn="bl" rotWithShape="0" blurRad="76200" dist="25400" dir="5400000">
+              <a:srgbClr val="000000">
+                <a:alpha val="12000"/>
+              </a:srgbClr>
+            </a:outerShdw>
+          </a:effectLst>
+        </p:spPr>
+      </p:sp>
+      <p:sp>
+        <p:nvSpPr>
+          <p:cNvPr id="6" name="Shape 3"/>
+          <p:cNvSpPr/>
+          <p:nvPr/>
+        </p:nvSpPr>
+        <p:spPr>
+          <a:xfrm>
+            <a:off x="685800" y="1417320"/>
+            <a:ext cx="548640" cy="548640"/>
+          </a:xfrm>
+          <a:prstGeom prst="ellipse">
+            <a:avLst/>
+          </a:prstGeom>
+          <a:solidFill>
+            <a:srgbClr val="C01F53"/>
+          </a:solidFill>
+          <a:ln w="12700">
+            <a:solidFill>
+              <a:srgbClr val="C01F53"/>
+            </a:solidFill>
+            <a:prstDash val="solid"/>
+          </a:ln>
+        </p:spPr>
+      </p:sp>
+      <p:pic>
+        <p:nvPicPr>
+          <p:cNvPr id="7" name="Image 1" descr="preencoded.png">    </p:cNvPr>
+          <p:cNvPicPr>
+            <a:picLocks noChangeAspect="1"/>
+          </p:cNvPicPr>
+          <p:nvPr/>
+        </p:nvPicPr>
+        <p:blipFill>
+          <a:blip r:embed="rId2"/>
+          <a:stretch>
+            <a:fillRect/>
+          </a:stretch>
+        </p:blipFill>
+        <p:spPr>
+          <a:xfrm>
+            <a:off x="822960" y="1554480"/>
+            <a:ext cx="274320" cy="274320"/>
+          </a:xfrm>
+          <a:prstGeom prst="rect">
+            <a:avLst/>
+          </a:prstGeom>
+        </p:spPr>
+      </p:pic>
+      <p:sp>
+        <p:nvSpPr>
+          <p:cNvPr id="8" name="Text 4"/>
+          <p:cNvSpPr txBox="1"/>
+          <p:nvPr/>
+        </p:nvSpPr>
+        <p:spPr>
+          <a:xfrm>
+            <a:off x="1371600" y="1417320"/>
+            <a:ext cx="2926080" cy="548640"/>
+          </a:xfrm>
+          <a:prstGeom prst="rect">
+            <a:avLst/>
+          </a:prstGeom>
+          <a:noFill/>
+          <a:ln/>
+        </p:spPr>
+        <p:txBody>
+          <a:bodyPr wrap="square" lIns="0" tIns="0" rIns="0" bIns="0" rtlCol="0" anchor="ctr"/>
+          <a:lstStyle/>
+          <a:p>
+            <a:pPr indent="0" marL="0">
+              <a:buNone/>
+            </a:pPr>
+            <a:r>
+              <a:rPr lang="en-US" sz="1600" b="1" dirty="0">
+                <a:solidFill>
+                  <a:srgbClr val="2B1A22"/>
+                </a:solidFill>
+                <a:latin typeface="Arial" pitchFamily="34" charset="0"/>
+                <a:ea typeface="Arial" pitchFamily="34" charset="-122"/>
+                <a:cs typeface="Arial" pitchFamily="34" charset="-120"/>
+              </a:rPr>
+              <a:t>Counsellor must include</a:t>
+            </a:r>
+            <a:endParaRPr lang="en-US" sz="1600" dirty="0"/>
+          </a:p>
+        </p:txBody>
+      </p:sp>
+      <p:sp>
+        <p:nvSpPr>
+          <p:cNvPr id="9" name="Text 5"/>
+          <p:cNvSpPr txBox="1"/>
+          <p:nvPr/>
+        </p:nvSpPr>
+        <p:spPr>
+          <a:xfrm>
+            <a:off x="731520" y="2194560"/>
+            <a:ext cx="3520440" cy="2331720"/>
+          </a:xfrm>
+          <a:prstGeom prst="rect">
+            <a:avLst/>
+          </a:prstGeom>
+          <a:noFill/>
+          <a:ln/>
+        </p:spPr>
+        <p:txBody>
+          <a:bodyPr wrap="square" lIns="0" tIns="0" rIns="0" bIns="0" rtlCol="0" anchor="t"/>
+          <a:lstStyle/>
+          <a:p>
+            <a:pPr marL="342900" indent="-342900">
+              <a:spcAft>
+                <a:spcPts val="800"/>
+              </a:spcAft>
+              <a:buSzPct val="100000"/>
+              <a:buChar char="•"/>
+            </a:pPr>
+            <a:r>
+              <a:rPr lang="en-US" sz="1400" dirty="0">
+                <a:solidFill>
+                  <a:srgbClr val="2B1A22"/>
+                </a:solidFill>
+                <a:latin typeface="Calibri" pitchFamily="34" charset="0"/>
+                <a:ea typeface="Calibri" pitchFamily="34" charset="-122"/>
+                <a:cs typeface="Calibri" pitchFamily="34" charset="-120"/>
+              </a:rPr>
+              <a:t>All relevant information from the student</a:t>
+            </a:r>
+            <a:endParaRPr lang="en-US" sz="1400" dirty="0"/>
+          </a:p>
+          <a:p>
+            <a:pPr marL="342900" indent="-342900">
+              <a:spcAft>
+                <a:spcPts val="800"/>
+              </a:spcAft>
+              <a:buSzPct val="100000"/>
+              <a:buChar char="•"/>
+            </a:pPr>
+            <a:r>
+              <a:rPr lang="en-US" sz="1400" dirty="0">
+                <a:solidFill>
+                  <a:srgbClr val="2B1A22"/>
+                </a:solidFill>
+                <a:latin typeface="Calibri" pitchFamily="34" charset="0"/>
+                <a:ea typeface="Calibri" pitchFamily="34" charset="-122"/>
+                <a:cs typeface="Calibri" pitchFamily="34" charset="-120"/>
+              </a:rPr>
+              <a:t>Accurately completed Refund Request Form</a:t>
+            </a:r>
+            <a:endParaRPr lang="en-US" sz="1400" dirty="0"/>
+          </a:p>
+          <a:p>
+            <a:pPr marL="342900" indent="-342900">
+              <a:spcAft>
+                <a:spcPts val="800"/>
+              </a:spcAft>
+              <a:buSzPct val="100000"/>
+              <a:buChar char="•"/>
+            </a:pPr>
+            <a:r>
+              <a:rPr lang="en-US" sz="1400" dirty="0">
+                <a:solidFill>
+                  <a:srgbClr val="2B1A22"/>
+                </a:solidFill>
+                <a:latin typeface="Calibri" pitchFamily="34" charset="0"/>
+                <a:ea typeface="Calibri" pitchFamily="34" charset="-122"/>
+                <a:cs typeface="Calibri" pitchFamily="34" charset="-120"/>
+              </a:rPr>
+              <a:t>Supporting information for the request</a:t>
+            </a:r>
+            <a:endParaRPr lang="en-US" sz="1400" dirty="0"/>
+          </a:p>
+          <a:p>
+            <a:pPr marL="342900" indent="-342900">
+              <a:spcAft>
+                <a:spcPts val="800"/>
+              </a:spcAft>
+              <a:buSzPct val="100000"/>
+              <a:buChar char="•"/>
+            </a:pPr>
+            <a:r>
+              <a:rPr lang="en-US" sz="1400" dirty="0">
+                <a:solidFill>
+                  <a:srgbClr val="2B1A22"/>
+                </a:solidFill>
+                <a:latin typeface="Calibri" pitchFamily="34" charset="0"/>
+                <a:ea typeface="Calibri" pitchFamily="34" charset="-122"/>
+                <a:cs typeface="Calibri" pitchFamily="34" charset="-120"/>
+              </a:rPr>
+              <a:t>Incentives already received / claimed for this student or application</a:t>
+            </a:r>
+            <a:endParaRPr lang="en-US" sz="1400" dirty="0"/>
+          </a:p>
+        </p:txBody>
+      </p:sp>
+      <p:sp>
+        <p:nvSpPr>
+          <p:cNvPr id="10" name="Shape 6"/>
+          <p:cNvSpPr/>
+          <p:nvPr/>
+        </p:nvSpPr>
+        <p:spPr>
+          <a:xfrm>
+            <a:off x="4663440" y="1234440"/>
+            <a:ext cx="3977640" cy="3429000"/>
+          </a:xfrm>
+          <a:prstGeom prst="roundRect">
+            <a:avLst>
+              <a:gd name="adj" fmla="val 3200"/>
+            </a:avLst>
+          </a:prstGeom>
+          <a:solidFill>
+            <a:srgbClr val="FBEFF3"/>
+          </a:solidFill>
+          <a:ln w="9525">
+            <a:solidFill>
+              <a:srgbClr val="EBD3DC"/>
+            </a:solidFill>
+            <a:prstDash val="solid"/>
+          </a:ln>
+          <a:effectLst>
+            <a:outerShdw sx="100000" sy="100000" kx="0" ky="0" algn="bl" rotWithShape="0" blurRad="76200" dist="25400" dir="5400000">
+              <a:srgbClr val="000000">
+                <a:alpha val="12000"/>
+              </a:srgbClr>
+            </a:outerShdw>
+          </a:effectLst>
+        </p:spPr>
+      </p:sp>
+      <p:sp>
+        <p:nvSpPr>
+          <p:cNvPr id="11" name="Shape 7"/>
+          <p:cNvSpPr/>
+          <p:nvPr/>
+        </p:nvSpPr>
+        <p:spPr>
+          <a:xfrm>
+            <a:off x="4892040" y="1417320"/>
+            <a:ext cx="548640" cy="548640"/>
+          </a:xfrm>
+          <a:prstGeom prst="ellipse">
+            <a:avLst/>
+          </a:prstGeom>
+          <a:solidFill>
+            <a:srgbClr val="C01F53"/>
+          </a:solidFill>
+          <a:ln w="12700">
+            <a:solidFill>
+              <a:srgbClr val="C01F53"/>
+            </a:solidFill>
+            <a:prstDash val="solid"/>
+          </a:ln>
+        </p:spPr>
+      </p:sp>
+      <p:pic>
+        <p:nvPicPr>
+          <p:cNvPr id="12" name="Image 2" descr="preencoded.png">    </p:cNvPr>
+          <p:cNvPicPr>
+            <a:picLocks noChangeAspect="1"/>
+          </p:cNvPicPr>
+          <p:nvPr/>
+        </p:nvPicPr>
+        <p:blipFill>
+          <a:blip r:embed="rId3"/>
+          <a:stretch>
+            <a:fillRect/>
+          </a:stretch>
+        </p:blipFill>
+        <p:spPr>
+          <a:xfrm>
+            <a:off x="5029200" y="1554480"/>
+            <a:ext cx="274320" cy="274320"/>
+          </a:xfrm>
+          <a:prstGeom prst="rect">
+            <a:avLst/>
+          </a:prstGeom>
+        </p:spPr>
+      </p:pic>
+      <p:sp>
+        <p:nvSpPr>
+          <p:cNvPr id="13" name="Text 8"/>
+          <p:cNvSpPr txBox="1"/>
+          <p:nvPr/>
+        </p:nvSpPr>
+        <p:spPr>
+          <a:xfrm>
+            <a:off x="5577840" y="1417320"/>
+            <a:ext cx="2926080" cy="548640"/>
+          </a:xfrm>
+          <a:prstGeom prst="rect">
+            <a:avLst/>
+          </a:prstGeom>
+          <a:noFill/>
+          <a:ln/>
+        </p:spPr>
+        <p:txBody>
+          <a:bodyPr wrap="square" lIns="0" tIns="0" rIns="0" bIns="0" rtlCol="0" anchor="ctr"/>
+          <a:lstStyle/>
+          <a:p>
+            <a:pPr indent="0" marL="0">
+              <a:buNone/>
+            </a:pPr>
+            <a:r>
+              <a:rPr lang="en-US" sz="1600" b="1" dirty="0">
+                <a:solidFill>
+                  <a:srgbClr val="2B1A22"/>
+                </a:solidFill>
+                <a:latin typeface="Arial" pitchFamily="34" charset="0"/>
+                <a:ea typeface="Arial" pitchFamily="34" charset="-122"/>
+                <a:cs typeface="Arial" pitchFamily="34" charset="-120"/>
+              </a:rPr>
+              <a:t>IRM verifies</a:t>
+            </a:r>
+            <a:endParaRPr lang="en-US" sz="1600" dirty="0"/>
+          </a:p>
+        </p:txBody>
+      </p:sp>
+      <p:sp>
+        <p:nvSpPr>
+          <p:cNvPr id="14" name="Text 9"/>
+          <p:cNvSpPr txBox="1"/>
+          <p:nvPr/>
+        </p:nvSpPr>
+        <p:spPr>
+          <a:xfrm>
+            <a:off x="4937760" y="2194560"/>
+            <a:ext cx="3520440" cy="2331720"/>
+          </a:xfrm>
+          <a:prstGeom prst="rect">
+            <a:avLst/>
+          </a:prstGeom>
+          <a:noFill/>
+          <a:ln/>
+        </p:spPr>
+        <p:txBody>
+          <a:bodyPr wrap="square" lIns="0" tIns="0" rIns="0" bIns="0" rtlCol="0" anchor="t"/>
+          <a:lstStyle/>
+          <a:p>
+            <a:pPr marL="342900" indent="-342900">
+              <a:spcAft>
+                <a:spcPts val="800"/>
+              </a:spcAft>
+              <a:buSzPct val="100000"/>
+              <a:buChar char="•"/>
+            </a:pPr>
+            <a:r>
+              <a:rPr lang="en-US" sz="1400" dirty="0">
+                <a:solidFill>
+                  <a:srgbClr val="2B1A22"/>
+                </a:solidFill>
+                <a:latin typeface="Calibri" pitchFamily="34" charset="0"/>
+                <a:ea typeface="Calibri" pitchFamily="34" charset="-122"/>
+                <a:cs typeface="Calibri" pitchFamily="34" charset="-120"/>
+              </a:rPr>
+              <a:t>Application status</a:t>
+            </a:r>
+            <a:endParaRPr lang="en-US" sz="1400" dirty="0"/>
+          </a:p>
+          <a:p>
+            <a:pPr marL="342900" indent="-342900">
+              <a:spcAft>
+                <a:spcPts val="800"/>
+              </a:spcAft>
+              <a:buSzPct val="100000"/>
+              <a:buChar char="•"/>
+            </a:pPr>
+            <a:r>
+              <a:rPr lang="en-US" sz="1400" dirty="0">
+                <a:solidFill>
+                  <a:srgbClr val="2B1A22"/>
+                </a:solidFill>
+                <a:latin typeface="Calibri" pitchFamily="34" charset="0"/>
+                <a:ea typeface="Calibri" pitchFamily="34" charset="-122"/>
+                <a:cs typeface="Calibri" pitchFamily="34" charset="-120"/>
+              </a:rPr>
+              <a:t>Payments made</a:t>
+            </a:r>
+            <a:endParaRPr lang="en-US" sz="1400" dirty="0"/>
+          </a:p>
+          <a:p>
+            <a:pPr marL="342900" indent="-342900">
+              <a:spcAft>
+                <a:spcPts val="800"/>
+              </a:spcAft>
+              <a:buSzPct val="100000"/>
+              <a:buChar char="•"/>
+            </a:pPr>
+            <a:r>
+              <a:rPr lang="en-US" sz="1400" dirty="0">
+                <a:solidFill>
+                  <a:srgbClr val="2B1A22"/>
+                </a:solidFill>
+                <a:latin typeface="Calibri" pitchFamily="34" charset="0"/>
+                <a:ea typeface="Calibri" pitchFamily="34" charset="-122"/>
+                <a:cs typeface="Calibri" pitchFamily="34" charset="-120"/>
+              </a:rPr>
+              <a:t>Services already provided</a:t>
+            </a:r>
+            <a:endParaRPr lang="en-US" sz="1400" dirty="0"/>
+          </a:p>
+          <a:p>
+            <a:pPr marL="342900" indent="-342900">
+              <a:spcAft>
+                <a:spcPts val="800"/>
+              </a:spcAft>
+              <a:buSzPct val="100000"/>
+              <a:buChar char="•"/>
+            </a:pPr>
+            <a:r>
+              <a:rPr lang="en-US" sz="1400" dirty="0">
+                <a:solidFill>
+                  <a:srgbClr val="2B1A22"/>
+                </a:solidFill>
+                <a:latin typeface="Calibri" pitchFamily="34" charset="0"/>
+                <a:ea typeface="Calibri" pitchFamily="34" charset="-122"/>
+                <a:cs typeface="Calibri" pitchFamily="34" charset="-120"/>
+              </a:rPr>
+              <a:t>Commitments given to the student</a:t>
+            </a:r>
+            <a:endParaRPr lang="en-US" sz="1400" dirty="0"/>
+          </a:p>
+          <a:p>
+            <a:pPr marL="342900" indent="-342900">
+              <a:spcAft>
+                <a:spcPts val="800"/>
+              </a:spcAft>
+              <a:buSzPct val="100000"/>
+              <a:buChar char="•"/>
+            </a:pPr>
+            <a:r>
+              <a:rPr lang="en-US" sz="1400" dirty="0">
+                <a:solidFill>
+                  <a:srgbClr val="2B1A22"/>
+                </a:solidFill>
+                <a:latin typeface="Calibri" pitchFamily="34" charset="0"/>
+                <a:ea typeface="Calibri" pitchFamily="34" charset="-122"/>
+                <a:cs typeface="Calibri" pitchFamily="34" charset="-120"/>
+              </a:rPr>
+              <a:t>Documentation on file</a:t>
+            </a:r>
+            <a:endParaRPr lang="en-US" sz="1400" dirty="0"/>
+          </a:p>
+        </p:txBody>
+      </p:sp>
+    </p:spTree>
+  </p:cSld>
+  <p:clrMapOvr>
+    <a:masterClrMapping/>
+  </p:clrMapOvr>
+</p:sld>
+</file>
+
+<file path=ppt/slides/slide16.xml><?xml version="1.0" encoding="utf-8"?>
+<p:sld xmlns:a="http://schemas.openxmlformats.org/drawingml/2006/main" xmlns:r="http://schemas.openxmlformats.org/officeDocument/2006/relationships" xmlns:p="http://schemas.openxmlformats.org/presentationml/2006/main">
+  <p:cSld name="Slide 16">
     <p:bg>
       <p:bgPr>
         <a:solidFill>

</xml_diff>